<commit_message>
Add non-SQL database support metrics and update readiness slide in Kettering assessment deck
</commit_message>
<xml_diff>
--- a/test-out.pptx
+++ b/test-out.pptx
@@ -15606,7 +15606,7 @@
                 </a:solidFill>
                 <a:latin typeface="Aptos"/>
               </a:rPr>
-              <a:t>MongoDB, MySQL, and PostgreSQL readiness from Strategy_PaaS_Preferred.xlsx.</a:t>
+              <a:t>Discovery footprint, support status, and PaaS readiness for MongoDB, MySQL, and PostgreSQL.</a:t>
             </a:r>
           </a:p>
         </p:txBody>
@@ -15619,8 +15619,8 @@
         </p:nvSpPr>
         <p:spPr>
           <a:xfrm>
-            <a:off x="640080" y="1234440"/>
-            <a:ext cx="10927080" cy="4846320"/>
+            <a:off x="594360" y="1097280"/>
+            <a:ext cx="5303520" cy="1783080"/>
           </a:xfrm>
           <a:prstGeom prst="roundRect">
             <a:avLst/>
@@ -15664,8 +15664,8 @@
         </p:nvSpPr>
         <p:spPr>
           <a:xfrm>
-            <a:off x="640080" y="1234440"/>
-            <a:ext cx="10927080" cy="73152"/>
+            <a:off x="594360" y="1097280"/>
+            <a:ext cx="5303520" cy="73152"/>
           </a:xfrm>
           <a:prstGeom prst="rect">
             <a:avLst/>
@@ -15707,8 +15707,8 @@
         </p:nvSpPr>
         <p:spPr>
           <a:xfrm>
-            <a:off x="777240" y="1362456"/>
-            <a:ext cx="10652759" cy="274320"/>
+            <a:off x="731520" y="1225295"/>
+            <a:ext cx="5029200" cy="274320"/>
           </a:xfrm>
           <a:prstGeom prst="rect">
             <a:avLst/>
@@ -15722,13 +15722,13 @@
           <a:lstStyle/>
           <a:p>
             <a:r>
-              <a:rPr sz="1700" b="1">
+              <a:rPr sz="1400" b="1">
                 <a:solidFill>
                   <a:srgbClr val="1E2761"/>
                 </a:solidFill>
                 <a:latin typeface="Aptos"/>
               </a:rPr>
-              <a:t>Readiness by database type</a:t>
+              <a:t>Discovery footprint</a:t>
             </a:r>
           </a:p>
         </p:txBody>
@@ -15741,8 +15741,1616 @@
         </p:nvSpPr>
         <p:spPr>
           <a:xfrm>
-            <a:off x="2331720" y="2057400"/>
-            <a:ext cx="2057400" cy="658368"/>
+            <a:off x="2148840" y="1572768"/>
+            <a:ext cx="1078992" cy="228600"/>
+          </a:xfrm>
+          <a:prstGeom prst="roundRect">
+            <a:avLst/>
+          </a:prstGeom>
+          <a:solidFill>
+            <a:srgbClr val="1E2761"/>
+          </a:solidFill>
+          <a:ln>
+            <a:noFill/>
+          </a:ln>
+        </p:spPr>
+        <p:style>
+          <a:lnRef idx="1">
+            <a:schemeClr val="accent1"/>
+          </a:lnRef>
+          <a:fillRef idx="3">
+            <a:schemeClr val="accent1"/>
+          </a:fillRef>
+          <a:effectRef idx="2">
+            <a:schemeClr val="accent1"/>
+          </a:effectRef>
+          <a:fontRef idx="minor">
+            <a:schemeClr val="lt1"/>
+          </a:fontRef>
+        </p:style>
+        <p:txBody>
+          <a:bodyPr rtlCol="0" anchor="ctr"/>
+          <a:lstStyle/>
+          <a:p>
+            <a:pPr algn="ctr"/>
+          </a:p>
+        </p:txBody>
+      </p:sp>
+      <p:sp>
+        <p:nvSpPr>
+          <p:cNvPr id="8" name="TextBox 7"/>
+          <p:cNvSpPr txBox="1"/>
+          <p:nvPr/>
+        </p:nvSpPr>
+        <p:spPr>
+          <a:xfrm>
+            <a:off x="2203704" y="1609344"/>
+            <a:ext cx="969264" cy="146304"/>
+          </a:xfrm>
+          <a:prstGeom prst="rect">
+            <a:avLst/>
+          </a:prstGeom>
+          <a:noFill/>
+        </p:spPr>
+        <p:txBody>
+          <a:bodyPr wrap="square" lIns="0" rIns="0" tIns="0" bIns="0">
+            <a:spAutoFit/>
+          </a:bodyPr>
+          <a:lstStyle/>
+          <a:p>
+            <a:pPr algn="ctr"/>
+            <a:r>
+              <a:rPr sz="900" b="1">
+                <a:solidFill>
+                  <a:srgbClr val="FFFFFF"/>
+                </a:solidFill>
+                <a:latin typeface="Aptos"/>
+              </a:rPr>
+              <a:t>Instances</a:t>
+            </a:r>
+          </a:p>
+        </p:txBody>
+      </p:sp>
+      <p:sp>
+        <p:nvSpPr>
+          <p:cNvPr id="9" name="Rounded Rectangle 8"/>
+          <p:cNvSpPr/>
+          <p:nvPr/>
+        </p:nvSpPr>
+        <p:spPr>
+          <a:xfrm>
+            <a:off x="3273552" y="1572768"/>
+            <a:ext cx="1078992" cy="228600"/>
+          </a:xfrm>
+          <a:prstGeom prst="roundRect">
+            <a:avLst/>
+          </a:prstGeom>
+          <a:solidFill>
+            <a:srgbClr val="1E2761"/>
+          </a:solidFill>
+          <a:ln>
+            <a:noFill/>
+          </a:ln>
+        </p:spPr>
+        <p:style>
+          <a:lnRef idx="1">
+            <a:schemeClr val="accent1"/>
+          </a:lnRef>
+          <a:fillRef idx="3">
+            <a:schemeClr val="accent1"/>
+          </a:fillRef>
+          <a:effectRef idx="2">
+            <a:schemeClr val="accent1"/>
+          </a:effectRef>
+          <a:fontRef idx="minor">
+            <a:schemeClr val="lt1"/>
+          </a:fontRef>
+        </p:style>
+        <p:txBody>
+          <a:bodyPr rtlCol="0" anchor="ctr"/>
+          <a:lstStyle/>
+          <a:p>
+            <a:pPr algn="ctr"/>
+          </a:p>
+        </p:txBody>
+      </p:sp>
+      <p:sp>
+        <p:nvSpPr>
+          <p:cNvPr id="10" name="TextBox 9"/>
+          <p:cNvSpPr txBox="1"/>
+          <p:nvPr/>
+        </p:nvSpPr>
+        <p:spPr>
+          <a:xfrm>
+            <a:off x="3328416" y="1609344"/>
+            <a:ext cx="969264" cy="146304"/>
+          </a:xfrm>
+          <a:prstGeom prst="rect">
+            <a:avLst/>
+          </a:prstGeom>
+          <a:noFill/>
+        </p:spPr>
+        <p:txBody>
+          <a:bodyPr wrap="square" lIns="0" rIns="0" tIns="0" bIns="0">
+            <a:spAutoFit/>
+          </a:bodyPr>
+          <a:lstStyle/>
+          <a:p>
+            <a:pPr algn="ctr"/>
+            <a:r>
+              <a:rPr sz="900" b="1">
+                <a:solidFill>
+                  <a:srgbClr val="FFFFFF"/>
+                </a:solidFill>
+                <a:latin typeface="Aptos"/>
+              </a:rPr>
+              <a:t>Servers</a:t>
+            </a:r>
+          </a:p>
+        </p:txBody>
+      </p:sp>
+      <p:sp>
+        <p:nvSpPr>
+          <p:cNvPr id="11" name="Rounded Rectangle 10"/>
+          <p:cNvSpPr/>
+          <p:nvPr/>
+        </p:nvSpPr>
+        <p:spPr>
+          <a:xfrm>
+            <a:off x="4398264" y="1572768"/>
+            <a:ext cx="1078992" cy="228600"/>
+          </a:xfrm>
+          <a:prstGeom prst="roundRect">
+            <a:avLst/>
+          </a:prstGeom>
+          <a:solidFill>
+            <a:srgbClr val="1E2761"/>
+          </a:solidFill>
+          <a:ln>
+            <a:noFill/>
+          </a:ln>
+        </p:spPr>
+        <p:style>
+          <a:lnRef idx="1">
+            <a:schemeClr val="accent1"/>
+          </a:lnRef>
+          <a:fillRef idx="3">
+            <a:schemeClr val="accent1"/>
+          </a:fillRef>
+          <a:effectRef idx="2">
+            <a:schemeClr val="accent1"/>
+          </a:effectRef>
+          <a:fontRef idx="minor">
+            <a:schemeClr val="lt1"/>
+          </a:fontRef>
+        </p:style>
+        <p:txBody>
+          <a:bodyPr rtlCol="0" anchor="ctr"/>
+          <a:lstStyle/>
+          <a:p>
+            <a:pPr algn="ctr"/>
+          </a:p>
+        </p:txBody>
+      </p:sp>
+      <p:sp>
+        <p:nvSpPr>
+          <p:cNvPr id="12" name="TextBox 11"/>
+          <p:cNvSpPr txBox="1"/>
+          <p:nvPr/>
+        </p:nvSpPr>
+        <p:spPr>
+          <a:xfrm>
+            <a:off x="4453128" y="1609344"/>
+            <a:ext cx="969264" cy="146304"/>
+          </a:xfrm>
+          <a:prstGeom prst="rect">
+            <a:avLst/>
+          </a:prstGeom>
+          <a:noFill/>
+        </p:spPr>
+        <p:txBody>
+          <a:bodyPr wrap="square" lIns="0" rIns="0" tIns="0" bIns="0">
+            <a:spAutoFit/>
+          </a:bodyPr>
+          <a:lstStyle/>
+          <a:p>
+            <a:pPr algn="ctr"/>
+            <a:r>
+              <a:rPr sz="900" b="1">
+                <a:solidFill>
+                  <a:srgbClr val="FFFFFF"/>
+                </a:solidFill>
+                <a:latin typeface="Aptos"/>
+              </a:rPr>
+              <a:t>Versions</a:t>
+            </a:r>
+          </a:p>
+        </p:txBody>
+      </p:sp>
+      <p:sp>
+        <p:nvSpPr>
+          <p:cNvPr id="13" name="TextBox 12"/>
+          <p:cNvSpPr txBox="1"/>
+          <p:nvPr/>
+        </p:nvSpPr>
+        <p:spPr>
+          <a:xfrm>
+            <a:off x="822960" y="1883664"/>
+            <a:ext cx="1078992" cy="164592"/>
+          </a:xfrm>
+          <a:prstGeom prst="rect">
+            <a:avLst/>
+          </a:prstGeom>
+          <a:noFill/>
+        </p:spPr>
+        <p:txBody>
+          <a:bodyPr wrap="square" lIns="0" rIns="0" tIns="0" bIns="0">
+            <a:spAutoFit/>
+          </a:bodyPr>
+          <a:lstStyle/>
+          <a:p>
+            <a:r>
+              <a:rPr sz="1000" b="1">
+                <a:solidFill>
+                  <a:srgbClr val="1E2761"/>
+                </a:solidFill>
+                <a:latin typeface="Aptos"/>
+              </a:rPr>
+              <a:t>MongoDB</a:t>
+            </a:r>
+          </a:p>
+        </p:txBody>
+      </p:sp>
+      <p:sp>
+        <p:nvSpPr>
+          <p:cNvPr id="14" name="Rounded Rectangle 13"/>
+          <p:cNvSpPr/>
+          <p:nvPr/>
+        </p:nvSpPr>
+        <p:spPr>
+          <a:xfrm>
+            <a:off x="2148840" y="1847088"/>
+            <a:ext cx="1078992" cy="228600"/>
+          </a:xfrm>
+          <a:prstGeom prst="roundRect">
+            <a:avLst/>
+          </a:prstGeom>
+          <a:solidFill>
+            <a:srgbClr val="F1F5F9"/>
+          </a:solidFill>
+          <a:ln w="12700">
+            <a:solidFill>
+              <a:srgbClr val="FFFFFF"/>
+            </a:solidFill>
+          </a:ln>
+        </p:spPr>
+        <p:style>
+          <a:lnRef idx="1">
+            <a:schemeClr val="accent1"/>
+          </a:lnRef>
+          <a:fillRef idx="3">
+            <a:schemeClr val="accent1"/>
+          </a:fillRef>
+          <a:effectRef idx="2">
+            <a:schemeClr val="accent1"/>
+          </a:effectRef>
+          <a:fontRef idx="minor">
+            <a:schemeClr val="lt1"/>
+          </a:fontRef>
+        </p:style>
+        <p:txBody>
+          <a:bodyPr rtlCol="0" anchor="ctr"/>
+          <a:lstStyle/>
+          <a:p>
+            <a:pPr algn="ctr"/>
+          </a:p>
+        </p:txBody>
+      </p:sp>
+      <p:sp>
+        <p:nvSpPr>
+          <p:cNvPr id="15" name="TextBox 14"/>
+          <p:cNvSpPr txBox="1"/>
+          <p:nvPr/>
+        </p:nvSpPr>
+        <p:spPr>
+          <a:xfrm>
+            <a:off x="2203704" y="1883664"/>
+            <a:ext cx="969264" cy="137160"/>
+          </a:xfrm>
+          <a:prstGeom prst="rect">
+            <a:avLst/>
+          </a:prstGeom>
+          <a:noFill/>
+        </p:spPr>
+        <p:txBody>
+          <a:bodyPr wrap="square" lIns="0" rIns="0" tIns="0" bIns="0">
+            <a:spAutoFit/>
+          </a:bodyPr>
+          <a:lstStyle/>
+          <a:p>
+            <a:pPr algn="ctr"/>
+            <a:r>
+              <a:rPr sz="900" b="1">
+                <a:solidFill>
+                  <a:srgbClr val="1E2761"/>
+                </a:solidFill>
+                <a:latin typeface="Aptos"/>
+              </a:rPr>
+              <a:t>19</a:t>
+            </a:r>
+          </a:p>
+        </p:txBody>
+      </p:sp>
+      <p:sp>
+        <p:nvSpPr>
+          <p:cNvPr id="16" name="Rounded Rectangle 15"/>
+          <p:cNvSpPr/>
+          <p:nvPr/>
+        </p:nvSpPr>
+        <p:spPr>
+          <a:xfrm>
+            <a:off x="3273552" y="1847088"/>
+            <a:ext cx="1078992" cy="228600"/>
+          </a:xfrm>
+          <a:prstGeom prst="roundRect">
+            <a:avLst/>
+          </a:prstGeom>
+          <a:solidFill>
+            <a:srgbClr val="F1F5F9"/>
+          </a:solidFill>
+          <a:ln w="12700">
+            <a:solidFill>
+              <a:srgbClr val="FFFFFF"/>
+            </a:solidFill>
+          </a:ln>
+        </p:spPr>
+        <p:style>
+          <a:lnRef idx="1">
+            <a:schemeClr val="accent1"/>
+          </a:lnRef>
+          <a:fillRef idx="3">
+            <a:schemeClr val="accent1"/>
+          </a:fillRef>
+          <a:effectRef idx="2">
+            <a:schemeClr val="accent1"/>
+          </a:effectRef>
+          <a:fontRef idx="minor">
+            <a:schemeClr val="lt1"/>
+          </a:fontRef>
+        </p:style>
+        <p:txBody>
+          <a:bodyPr rtlCol="0" anchor="ctr"/>
+          <a:lstStyle/>
+          <a:p>
+            <a:pPr algn="ctr"/>
+          </a:p>
+        </p:txBody>
+      </p:sp>
+      <p:sp>
+        <p:nvSpPr>
+          <p:cNvPr id="17" name="TextBox 16"/>
+          <p:cNvSpPr txBox="1"/>
+          <p:nvPr/>
+        </p:nvSpPr>
+        <p:spPr>
+          <a:xfrm>
+            <a:off x="3328416" y="1883664"/>
+            <a:ext cx="969264" cy="137160"/>
+          </a:xfrm>
+          <a:prstGeom prst="rect">
+            <a:avLst/>
+          </a:prstGeom>
+          <a:noFill/>
+        </p:spPr>
+        <p:txBody>
+          <a:bodyPr wrap="square" lIns="0" rIns="0" tIns="0" bIns="0">
+            <a:spAutoFit/>
+          </a:bodyPr>
+          <a:lstStyle/>
+          <a:p>
+            <a:pPr algn="ctr"/>
+            <a:r>
+              <a:rPr sz="900" b="1">
+                <a:solidFill>
+                  <a:srgbClr val="1E2761"/>
+                </a:solidFill>
+                <a:latin typeface="Aptos"/>
+              </a:rPr>
+              <a:t>19</a:t>
+            </a:r>
+          </a:p>
+        </p:txBody>
+      </p:sp>
+      <p:sp>
+        <p:nvSpPr>
+          <p:cNvPr id="18" name="Rounded Rectangle 17"/>
+          <p:cNvSpPr/>
+          <p:nvPr/>
+        </p:nvSpPr>
+        <p:spPr>
+          <a:xfrm>
+            <a:off x="4398264" y="1847088"/>
+            <a:ext cx="1078992" cy="228600"/>
+          </a:xfrm>
+          <a:prstGeom prst="roundRect">
+            <a:avLst/>
+          </a:prstGeom>
+          <a:solidFill>
+            <a:srgbClr val="F1F5F9"/>
+          </a:solidFill>
+          <a:ln w="12700">
+            <a:solidFill>
+              <a:srgbClr val="FFFFFF"/>
+            </a:solidFill>
+          </a:ln>
+        </p:spPr>
+        <p:style>
+          <a:lnRef idx="1">
+            <a:schemeClr val="accent1"/>
+          </a:lnRef>
+          <a:fillRef idx="3">
+            <a:schemeClr val="accent1"/>
+          </a:fillRef>
+          <a:effectRef idx="2">
+            <a:schemeClr val="accent1"/>
+          </a:effectRef>
+          <a:fontRef idx="minor">
+            <a:schemeClr val="lt1"/>
+          </a:fontRef>
+        </p:style>
+        <p:txBody>
+          <a:bodyPr rtlCol="0" anchor="ctr"/>
+          <a:lstStyle/>
+          <a:p>
+            <a:pPr algn="ctr"/>
+          </a:p>
+        </p:txBody>
+      </p:sp>
+      <p:sp>
+        <p:nvSpPr>
+          <p:cNvPr id="19" name="TextBox 18"/>
+          <p:cNvSpPr txBox="1"/>
+          <p:nvPr/>
+        </p:nvSpPr>
+        <p:spPr>
+          <a:xfrm>
+            <a:off x="4453128" y="1883664"/>
+            <a:ext cx="969264" cy="137160"/>
+          </a:xfrm>
+          <a:prstGeom prst="rect">
+            <a:avLst/>
+          </a:prstGeom>
+          <a:noFill/>
+        </p:spPr>
+        <p:txBody>
+          <a:bodyPr wrap="square" lIns="0" rIns="0" tIns="0" bIns="0">
+            <a:spAutoFit/>
+          </a:bodyPr>
+          <a:lstStyle/>
+          <a:p>
+            <a:pPr algn="ctr"/>
+            <a:r>
+              <a:rPr sz="900" b="1">
+                <a:solidFill>
+                  <a:srgbClr val="1E2761"/>
+                </a:solidFill>
+                <a:latin typeface="Aptos"/>
+              </a:rPr>
+              <a:t>5</a:t>
+            </a:r>
+          </a:p>
+        </p:txBody>
+      </p:sp>
+      <p:sp>
+        <p:nvSpPr>
+          <p:cNvPr id="20" name="TextBox 19"/>
+          <p:cNvSpPr txBox="1"/>
+          <p:nvPr/>
+        </p:nvSpPr>
+        <p:spPr>
+          <a:xfrm>
+            <a:off x="822960" y="2157984"/>
+            <a:ext cx="1078992" cy="164592"/>
+          </a:xfrm>
+          <a:prstGeom prst="rect">
+            <a:avLst/>
+          </a:prstGeom>
+          <a:noFill/>
+        </p:spPr>
+        <p:txBody>
+          <a:bodyPr wrap="square" lIns="0" rIns="0" tIns="0" bIns="0">
+            <a:spAutoFit/>
+          </a:bodyPr>
+          <a:lstStyle/>
+          <a:p>
+            <a:r>
+              <a:rPr sz="1000" b="1">
+                <a:solidFill>
+                  <a:srgbClr val="1E2761"/>
+                </a:solidFill>
+                <a:latin typeface="Aptos"/>
+              </a:rPr>
+              <a:t>MySQL</a:t>
+            </a:r>
+          </a:p>
+        </p:txBody>
+      </p:sp>
+      <p:sp>
+        <p:nvSpPr>
+          <p:cNvPr id="21" name="Rounded Rectangle 20"/>
+          <p:cNvSpPr/>
+          <p:nvPr/>
+        </p:nvSpPr>
+        <p:spPr>
+          <a:xfrm>
+            <a:off x="2148840" y="2121408"/>
+            <a:ext cx="1078992" cy="228600"/>
+          </a:xfrm>
+          <a:prstGeom prst="roundRect">
+            <a:avLst/>
+          </a:prstGeom>
+          <a:solidFill>
+            <a:srgbClr val="F1F5F9"/>
+          </a:solidFill>
+          <a:ln w="12700">
+            <a:solidFill>
+              <a:srgbClr val="FFFFFF"/>
+            </a:solidFill>
+          </a:ln>
+        </p:spPr>
+        <p:style>
+          <a:lnRef idx="1">
+            <a:schemeClr val="accent1"/>
+          </a:lnRef>
+          <a:fillRef idx="3">
+            <a:schemeClr val="accent1"/>
+          </a:fillRef>
+          <a:effectRef idx="2">
+            <a:schemeClr val="accent1"/>
+          </a:effectRef>
+          <a:fontRef idx="minor">
+            <a:schemeClr val="lt1"/>
+          </a:fontRef>
+        </p:style>
+        <p:txBody>
+          <a:bodyPr rtlCol="0" anchor="ctr"/>
+          <a:lstStyle/>
+          <a:p>
+            <a:pPr algn="ctr"/>
+          </a:p>
+        </p:txBody>
+      </p:sp>
+      <p:sp>
+        <p:nvSpPr>
+          <p:cNvPr id="22" name="TextBox 21"/>
+          <p:cNvSpPr txBox="1"/>
+          <p:nvPr/>
+        </p:nvSpPr>
+        <p:spPr>
+          <a:xfrm>
+            <a:off x="2203704" y="2157984"/>
+            <a:ext cx="969264" cy="137160"/>
+          </a:xfrm>
+          <a:prstGeom prst="rect">
+            <a:avLst/>
+          </a:prstGeom>
+          <a:noFill/>
+        </p:spPr>
+        <p:txBody>
+          <a:bodyPr wrap="square" lIns="0" rIns="0" tIns="0" bIns="0">
+            <a:spAutoFit/>
+          </a:bodyPr>
+          <a:lstStyle/>
+          <a:p>
+            <a:pPr algn="ctr"/>
+            <a:r>
+              <a:rPr sz="900" b="1">
+                <a:solidFill>
+                  <a:srgbClr val="1E2761"/>
+                </a:solidFill>
+                <a:latin typeface="Aptos"/>
+              </a:rPr>
+              <a:t>11</a:t>
+            </a:r>
+          </a:p>
+        </p:txBody>
+      </p:sp>
+      <p:sp>
+        <p:nvSpPr>
+          <p:cNvPr id="23" name="Rounded Rectangle 22"/>
+          <p:cNvSpPr/>
+          <p:nvPr/>
+        </p:nvSpPr>
+        <p:spPr>
+          <a:xfrm>
+            <a:off x="3273552" y="2121408"/>
+            <a:ext cx="1078992" cy="228600"/>
+          </a:xfrm>
+          <a:prstGeom prst="roundRect">
+            <a:avLst/>
+          </a:prstGeom>
+          <a:solidFill>
+            <a:srgbClr val="F1F5F9"/>
+          </a:solidFill>
+          <a:ln w="12700">
+            <a:solidFill>
+              <a:srgbClr val="FFFFFF"/>
+            </a:solidFill>
+          </a:ln>
+        </p:spPr>
+        <p:style>
+          <a:lnRef idx="1">
+            <a:schemeClr val="accent1"/>
+          </a:lnRef>
+          <a:fillRef idx="3">
+            <a:schemeClr val="accent1"/>
+          </a:fillRef>
+          <a:effectRef idx="2">
+            <a:schemeClr val="accent1"/>
+          </a:effectRef>
+          <a:fontRef idx="minor">
+            <a:schemeClr val="lt1"/>
+          </a:fontRef>
+        </p:style>
+        <p:txBody>
+          <a:bodyPr rtlCol="0" anchor="ctr"/>
+          <a:lstStyle/>
+          <a:p>
+            <a:pPr algn="ctr"/>
+          </a:p>
+        </p:txBody>
+      </p:sp>
+      <p:sp>
+        <p:nvSpPr>
+          <p:cNvPr id="24" name="TextBox 23"/>
+          <p:cNvSpPr txBox="1"/>
+          <p:nvPr/>
+        </p:nvSpPr>
+        <p:spPr>
+          <a:xfrm>
+            <a:off x="3328416" y="2157984"/>
+            <a:ext cx="969264" cy="137160"/>
+          </a:xfrm>
+          <a:prstGeom prst="rect">
+            <a:avLst/>
+          </a:prstGeom>
+          <a:noFill/>
+        </p:spPr>
+        <p:txBody>
+          <a:bodyPr wrap="square" lIns="0" rIns="0" tIns="0" bIns="0">
+            <a:spAutoFit/>
+          </a:bodyPr>
+          <a:lstStyle/>
+          <a:p>
+            <a:pPr algn="ctr"/>
+            <a:r>
+              <a:rPr sz="900" b="1">
+                <a:solidFill>
+                  <a:srgbClr val="1E2761"/>
+                </a:solidFill>
+                <a:latin typeface="Aptos"/>
+              </a:rPr>
+              <a:t>11</a:t>
+            </a:r>
+          </a:p>
+        </p:txBody>
+      </p:sp>
+      <p:sp>
+        <p:nvSpPr>
+          <p:cNvPr id="25" name="Rounded Rectangle 24"/>
+          <p:cNvSpPr/>
+          <p:nvPr/>
+        </p:nvSpPr>
+        <p:spPr>
+          <a:xfrm>
+            <a:off x="4398264" y="2121408"/>
+            <a:ext cx="1078992" cy="228600"/>
+          </a:xfrm>
+          <a:prstGeom prst="roundRect">
+            <a:avLst/>
+          </a:prstGeom>
+          <a:solidFill>
+            <a:srgbClr val="F1F5F9"/>
+          </a:solidFill>
+          <a:ln w="12700">
+            <a:solidFill>
+              <a:srgbClr val="FFFFFF"/>
+            </a:solidFill>
+          </a:ln>
+        </p:spPr>
+        <p:style>
+          <a:lnRef idx="1">
+            <a:schemeClr val="accent1"/>
+          </a:lnRef>
+          <a:fillRef idx="3">
+            <a:schemeClr val="accent1"/>
+          </a:fillRef>
+          <a:effectRef idx="2">
+            <a:schemeClr val="accent1"/>
+          </a:effectRef>
+          <a:fontRef idx="minor">
+            <a:schemeClr val="lt1"/>
+          </a:fontRef>
+        </p:style>
+        <p:txBody>
+          <a:bodyPr rtlCol="0" anchor="ctr"/>
+          <a:lstStyle/>
+          <a:p>
+            <a:pPr algn="ctr"/>
+          </a:p>
+        </p:txBody>
+      </p:sp>
+      <p:sp>
+        <p:nvSpPr>
+          <p:cNvPr id="26" name="TextBox 25"/>
+          <p:cNvSpPr txBox="1"/>
+          <p:nvPr/>
+        </p:nvSpPr>
+        <p:spPr>
+          <a:xfrm>
+            <a:off x="4453128" y="2157984"/>
+            <a:ext cx="969264" cy="137160"/>
+          </a:xfrm>
+          <a:prstGeom prst="rect">
+            <a:avLst/>
+          </a:prstGeom>
+          <a:noFill/>
+        </p:spPr>
+        <p:txBody>
+          <a:bodyPr wrap="square" lIns="0" rIns="0" tIns="0" bIns="0">
+            <a:spAutoFit/>
+          </a:bodyPr>
+          <a:lstStyle/>
+          <a:p>
+            <a:pPr algn="ctr"/>
+            <a:r>
+              <a:rPr sz="900" b="1">
+                <a:solidFill>
+                  <a:srgbClr val="1E2761"/>
+                </a:solidFill>
+                <a:latin typeface="Aptos"/>
+              </a:rPr>
+              <a:t>10</a:t>
+            </a:r>
+          </a:p>
+        </p:txBody>
+      </p:sp>
+      <p:sp>
+        <p:nvSpPr>
+          <p:cNvPr id="27" name="TextBox 26"/>
+          <p:cNvSpPr txBox="1"/>
+          <p:nvPr/>
+        </p:nvSpPr>
+        <p:spPr>
+          <a:xfrm>
+            <a:off x="822960" y="2432304"/>
+            <a:ext cx="1078992" cy="164592"/>
+          </a:xfrm>
+          <a:prstGeom prst="rect">
+            <a:avLst/>
+          </a:prstGeom>
+          <a:noFill/>
+        </p:spPr>
+        <p:txBody>
+          <a:bodyPr wrap="square" lIns="0" rIns="0" tIns="0" bIns="0">
+            <a:spAutoFit/>
+          </a:bodyPr>
+          <a:lstStyle/>
+          <a:p>
+            <a:r>
+              <a:rPr sz="1000" b="1">
+                <a:solidFill>
+                  <a:srgbClr val="1E2761"/>
+                </a:solidFill>
+                <a:latin typeface="Aptos"/>
+              </a:rPr>
+              <a:t>PostgreSQL</a:t>
+            </a:r>
+          </a:p>
+        </p:txBody>
+      </p:sp>
+      <p:sp>
+        <p:nvSpPr>
+          <p:cNvPr id="28" name="Rounded Rectangle 27"/>
+          <p:cNvSpPr/>
+          <p:nvPr/>
+        </p:nvSpPr>
+        <p:spPr>
+          <a:xfrm>
+            <a:off x="2148840" y="2395728"/>
+            <a:ext cx="1078992" cy="228600"/>
+          </a:xfrm>
+          <a:prstGeom prst="roundRect">
+            <a:avLst/>
+          </a:prstGeom>
+          <a:solidFill>
+            <a:srgbClr val="F1F5F9"/>
+          </a:solidFill>
+          <a:ln w="12700">
+            <a:solidFill>
+              <a:srgbClr val="FFFFFF"/>
+            </a:solidFill>
+          </a:ln>
+        </p:spPr>
+        <p:style>
+          <a:lnRef idx="1">
+            <a:schemeClr val="accent1"/>
+          </a:lnRef>
+          <a:fillRef idx="3">
+            <a:schemeClr val="accent1"/>
+          </a:fillRef>
+          <a:effectRef idx="2">
+            <a:schemeClr val="accent1"/>
+          </a:effectRef>
+          <a:fontRef idx="minor">
+            <a:schemeClr val="lt1"/>
+          </a:fontRef>
+        </p:style>
+        <p:txBody>
+          <a:bodyPr rtlCol="0" anchor="ctr"/>
+          <a:lstStyle/>
+          <a:p>
+            <a:pPr algn="ctr"/>
+          </a:p>
+        </p:txBody>
+      </p:sp>
+      <p:sp>
+        <p:nvSpPr>
+          <p:cNvPr id="29" name="TextBox 28"/>
+          <p:cNvSpPr txBox="1"/>
+          <p:nvPr/>
+        </p:nvSpPr>
+        <p:spPr>
+          <a:xfrm>
+            <a:off x="2203704" y="2432304"/>
+            <a:ext cx="969264" cy="137160"/>
+          </a:xfrm>
+          <a:prstGeom prst="rect">
+            <a:avLst/>
+          </a:prstGeom>
+          <a:noFill/>
+        </p:spPr>
+        <p:txBody>
+          <a:bodyPr wrap="square" lIns="0" rIns="0" tIns="0" bIns="0">
+            <a:spAutoFit/>
+          </a:bodyPr>
+          <a:lstStyle/>
+          <a:p>
+            <a:pPr algn="ctr"/>
+            <a:r>
+              <a:rPr sz="900" b="1">
+                <a:solidFill>
+                  <a:srgbClr val="1E2761"/>
+                </a:solidFill>
+                <a:latin typeface="Aptos"/>
+              </a:rPr>
+              <a:t>7</a:t>
+            </a:r>
+          </a:p>
+        </p:txBody>
+      </p:sp>
+      <p:sp>
+        <p:nvSpPr>
+          <p:cNvPr id="30" name="Rounded Rectangle 29"/>
+          <p:cNvSpPr/>
+          <p:nvPr/>
+        </p:nvSpPr>
+        <p:spPr>
+          <a:xfrm>
+            <a:off x="3273552" y="2395728"/>
+            <a:ext cx="1078992" cy="228600"/>
+          </a:xfrm>
+          <a:prstGeom prst="roundRect">
+            <a:avLst/>
+          </a:prstGeom>
+          <a:solidFill>
+            <a:srgbClr val="F1F5F9"/>
+          </a:solidFill>
+          <a:ln w="12700">
+            <a:solidFill>
+              <a:srgbClr val="FFFFFF"/>
+            </a:solidFill>
+          </a:ln>
+        </p:spPr>
+        <p:style>
+          <a:lnRef idx="1">
+            <a:schemeClr val="accent1"/>
+          </a:lnRef>
+          <a:fillRef idx="3">
+            <a:schemeClr val="accent1"/>
+          </a:fillRef>
+          <a:effectRef idx="2">
+            <a:schemeClr val="accent1"/>
+          </a:effectRef>
+          <a:fontRef idx="minor">
+            <a:schemeClr val="lt1"/>
+          </a:fontRef>
+        </p:style>
+        <p:txBody>
+          <a:bodyPr rtlCol="0" anchor="ctr"/>
+          <a:lstStyle/>
+          <a:p>
+            <a:pPr algn="ctr"/>
+          </a:p>
+        </p:txBody>
+      </p:sp>
+      <p:sp>
+        <p:nvSpPr>
+          <p:cNvPr id="31" name="TextBox 30"/>
+          <p:cNvSpPr txBox="1"/>
+          <p:nvPr/>
+        </p:nvSpPr>
+        <p:spPr>
+          <a:xfrm>
+            <a:off x="3328416" y="2432304"/>
+            <a:ext cx="969264" cy="137160"/>
+          </a:xfrm>
+          <a:prstGeom prst="rect">
+            <a:avLst/>
+          </a:prstGeom>
+          <a:noFill/>
+        </p:spPr>
+        <p:txBody>
+          <a:bodyPr wrap="square" lIns="0" rIns="0" tIns="0" bIns="0">
+            <a:spAutoFit/>
+          </a:bodyPr>
+          <a:lstStyle/>
+          <a:p>
+            <a:pPr algn="ctr"/>
+            <a:r>
+              <a:rPr sz="900" b="1">
+                <a:solidFill>
+                  <a:srgbClr val="1E2761"/>
+                </a:solidFill>
+                <a:latin typeface="Aptos"/>
+              </a:rPr>
+              <a:t>7</a:t>
+            </a:r>
+          </a:p>
+        </p:txBody>
+      </p:sp>
+      <p:sp>
+        <p:nvSpPr>
+          <p:cNvPr id="32" name="Rounded Rectangle 31"/>
+          <p:cNvSpPr/>
+          <p:nvPr/>
+        </p:nvSpPr>
+        <p:spPr>
+          <a:xfrm>
+            <a:off x="4398264" y="2395728"/>
+            <a:ext cx="1078992" cy="228600"/>
+          </a:xfrm>
+          <a:prstGeom prst="roundRect">
+            <a:avLst/>
+          </a:prstGeom>
+          <a:solidFill>
+            <a:srgbClr val="F1F5F9"/>
+          </a:solidFill>
+          <a:ln w="12700">
+            <a:solidFill>
+              <a:srgbClr val="FFFFFF"/>
+            </a:solidFill>
+          </a:ln>
+        </p:spPr>
+        <p:style>
+          <a:lnRef idx="1">
+            <a:schemeClr val="accent1"/>
+          </a:lnRef>
+          <a:fillRef idx="3">
+            <a:schemeClr val="accent1"/>
+          </a:fillRef>
+          <a:effectRef idx="2">
+            <a:schemeClr val="accent1"/>
+          </a:effectRef>
+          <a:fontRef idx="minor">
+            <a:schemeClr val="lt1"/>
+          </a:fontRef>
+        </p:style>
+        <p:txBody>
+          <a:bodyPr rtlCol="0" anchor="ctr"/>
+          <a:lstStyle/>
+          <a:p>
+            <a:pPr algn="ctr"/>
+          </a:p>
+        </p:txBody>
+      </p:sp>
+      <p:sp>
+        <p:nvSpPr>
+          <p:cNvPr id="33" name="TextBox 32"/>
+          <p:cNvSpPr txBox="1"/>
+          <p:nvPr/>
+        </p:nvSpPr>
+        <p:spPr>
+          <a:xfrm>
+            <a:off x="4453128" y="2432304"/>
+            <a:ext cx="969264" cy="137160"/>
+          </a:xfrm>
+          <a:prstGeom prst="rect">
+            <a:avLst/>
+          </a:prstGeom>
+          <a:noFill/>
+        </p:spPr>
+        <p:txBody>
+          <a:bodyPr wrap="square" lIns="0" rIns="0" tIns="0" bIns="0">
+            <a:spAutoFit/>
+          </a:bodyPr>
+          <a:lstStyle/>
+          <a:p>
+            <a:pPr algn="ctr"/>
+            <a:r>
+              <a:rPr sz="900" b="1">
+                <a:solidFill>
+                  <a:srgbClr val="1E2761"/>
+                </a:solidFill>
+                <a:latin typeface="Aptos"/>
+              </a:rPr>
+              <a:t>5</a:t>
+            </a:r>
+          </a:p>
+        </p:txBody>
+      </p:sp>
+      <p:sp>
+        <p:nvSpPr>
+          <p:cNvPr id="34" name="TextBox 33"/>
+          <p:cNvSpPr txBox="1"/>
+          <p:nvPr/>
+        </p:nvSpPr>
+        <p:spPr>
+          <a:xfrm>
+            <a:off x="822960" y="2706624"/>
+            <a:ext cx="1078992" cy="164592"/>
+          </a:xfrm>
+          <a:prstGeom prst="rect">
+            <a:avLst/>
+          </a:prstGeom>
+          <a:noFill/>
+        </p:spPr>
+        <p:txBody>
+          <a:bodyPr wrap="square" lIns="0" rIns="0" tIns="0" bIns="0">
+            <a:spAutoFit/>
+          </a:bodyPr>
+          <a:lstStyle/>
+          <a:p>
+            <a:r>
+              <a:rPr sz="1000" b="1">
+                <a:solidFill>
+                  <a:srgbClr val="1E2761"/>
+                </a:solidFill>
+                <a:latin typeface="Aptos"/>
+              </a:rPr>
+              <a:t>Total</a:t>
+            </a:r>
+          </a:p>
+        </p:txBody>
+      </p:sp>
+      <p:sp>
+        <p:nvSpPr>
+          <p:cNvPr id="35" name="Rounded Rectangle 34"/>
+          <p:cNvSpPr/>
+          <p:nvPr/>
+        </p:nvSpPr>
+        <p:spPr>
+          <a:xfrm>
+            <a:off x="2148840" y="2670048"/>
+            <a:ext cx="1078992" cy="228600"/>
+          </a:xfrm>
+          <a:prstGeom prst="roundRect">
+            <a:avLst/>
+          </a:prstGeom>
+          <a:solidFill>
+            <a:srgbClr val="1E2761"/>
+          </a:solidFill>
+          <a:ln w="12700">
+            <a:solidFill>
+              <a:srgbClr val="FFFFFF"/>
+            </a:solidFill>
+          </a:ln>
+        </p:spPr>
+        <p:style>
+          <a:lnRef idx="1">
+            <a:schemeClr val="accent1"/>
+          </a:lnRef>
+          <a:fillRef idx="3">
+            <a:schemeClr val="accent1"/>
+          </a:fillRef>
+          <a:effectRef idx="2">
+            <a:schemeClr val="accent1"/>
+          </a:effectRef>
+          <a:fontRef idx="minor">
+            <a:schemeClr val="lt1"/>
+          </a:fontRef>
+        </p:style>
+        <p:txBody>
+          <a:bodyPr rtlCol="0" anchor="ctr"/>
+          <a:lstStyle/>
+          <a:p>
+            <a:pPr algn="ctr"/>
+          </a:p>
+        </p:txBody>
+      </p:sp>
+      <p:sp>
+        <p:nvSpPr>
+          <p:cNvPr id="36" name="TextBox 35"/>
+          <p:cNvSpPr txBox="1"/>
+          <p:nvPr/>
+        </p:nvSpPr>
+        <p:spPr>
+          <a:xfrm>
+            <a:off x="2203704" y="2706624"/>
+            <a:ext cx="969264" cy="137160"/>
+          </a:xfrm>
+          <a:prstGeom prst="rect">
+            <a:avLst/>
+          </a:prstGeom>
+          <a:noFill/>
+        </p:spPr>
+        <p:txBody>
+          <a:bodyPr wrap="square" lIns="0" rIns="0" tIns="0" bIns="0">
+            <a:spAutoFit/>
+          </a:bodyPr>
+          <a:lstStyle/>
+          <a:p>
+            <a:pPr algn="ctr"/>
+            <a:r>
+              <a:rPr sz="900" b="1">
+                <a:solidFill>
+                  <a:srgbClr val="FFFFFF"/>
+                </a:solidFill>
+                <a:latin typeface="Aptos"/>
+              </a:rPr>
+              <a:t>37</a:t>
+            </a:r>
+          </a:p>
+        </p:txBody>
+      </p:sp>
+      <p:sp>
+        <p:nvSpPr>
+          <p:cNvPr id="37" name="Rounded Rectangle 36"/>
+          <p:cNvSpPr/>
+          <p:nvPr/>
+        </p:nvSpPr>
+        <p:spPr>
+          <a:xfrm>
+            <a:off x="3273552" y="2670048"/>
+            <a:ext cx="1078992" cy="228600"/>
+          </a:xfrm>
+          <a:prstGeom prst="roundRect">
+            <a:avLst/>
+          </a:prstGeom>
+          <a:solidFill>
+            <a:srgbClr val="1E2761"/>
+          </a:solidFill>
+          <a:ln w="12700">
+            <a:solidFill>
+              <a:srgbClr val="FFFFFF"/>
+            </a:solidFill>
+          </a:ln>
+        </p:spPr>
+        <p:style>
+          <a:lnRef idx="1">
+            <a:schemeClr val="accent1"/>
+          </a:lnRef>
+          <a:fillRef idx="3">
+            <a:schemeClr val="accent1"/>
+          </a:fillRef>
+          <a:effectRef idx="2">
+            <a:schemeClr val="accent1"/>
+          </a:effectRef>
+          <a:fontRef idx="minor">
+            <a:schemeClr val="lt1"/>
+          </a:fontRef>
+        </p:style>
+        <p:txBody>
+          <a:bodyPr rtlCol="0" anchor="ctr"/>
+          <a:lstStyle/>
+          <a:p>
+            <a:pPr algn="ctr"/>
+          </a:p>
+        </p:txBody>
+      </p:sp>
+      <p:sp>
+        <p:nvSpPr>
+          <p:cNvPr id="38" name="TextBox 37"/>
+          <p:cNvSpPr txBox="1"/>
+          <p:nvPr/>
+        </p:nvSpPr>
+        <p:spPr>
+          <a:xfrm>
+            <a:off x="3328416" y="2706624"/>
+            <a:ext cx="969264" cy="137160"/>
+          </a:xfrm>
+          <a:prstGeom prst="rect">
+            <a:avLst/>
+          </a:prstGeom>
+          <a:noFill/>
+        </p:spPr>
+        <p:txBody>
+          <a:bodyPr wrap="square" lIns="0" rIns="0" tIns="0" bIns="0">
+            <a:spAutoFit/>
+          </a:bodyPr>
+          <a:lstStyle/>
+          <a:p>
+            <a:pPr algn="ctr"/>
+            <a:r>
+              <a:rPr sz="900" b="1">
+                <a:solidFill>
+                  <a:srgbClr val="FFFFFF"/>
+                </a:solidFill>
+                <a:latin typeface="Aptos"/>
+              </a:rPr>
+              <a:t>37</a:t>
+            </a:r>
+          </a:p>
+        </p:txBody>
+      </p:sp>
+      <p:sp>
+        <p:nvSpPr>
+          <p:cNvPr id="39" name="Rounded Rectangle 38"/>
+          <p:cNvSpPr/>
+          <p:nvPr/>
+        </p:nvSpPr>
+        <p:spPr>
+          <a:xfrm>
+            <a:off x="4398264" y="2670048"/>
+            <a:ext cx="1078992" cy="228600"/>
+          </a:xfrm>
+          <a:prstGeom prst="roundRect">
+            <a:avLst/>
+          </a:prstGeom>
+          <a:solidFill>
+            <a:srgbClr val="1E2761"/>
+          </a:solidFill>
+          <a:ln w="12700">
+            <a:solidFill>
+              <a:srgbClr val="FFFFFF"/>
+            </a:solidFill>
+          </a:ln>
+        </p:spPr>
+        <p:style>
+          <a:lnRef idx="1">
+            <a:schemeClr val="accent1"/>
+          </a:lnRef>
+          <a:fillRef idx="3">
+            <a:schemeClr val="accent1"/>
+          </a:fillRef>
+          <a:effectRef idx="2">
+            <a:schemeClr val="accent1"/>
+          </a:effectRef>
+          <a:fontRef idx="minor">
+            <a:schemeClr val="lt1"/>
+          </a:fontRef>
+        </p:style>
+        <p:txBody>
+          <a:bodyPr rtlCol="0" anchor="ctr"/>
+          <a:lstStyle/>
+          <a:p>
+            <a:pPr algn="ctr"/>
+          </a:p>
+        </p:txBody>
+      </p:sp>
+      <p:sp>
+        <p:nvSpPr>
+          <p:cNvPr id="40" name="TextBox 39"/>
+          <p:cNvSpPr txBox="1"/>
+          <p:nvPr/>
+        </p:nvSpPr>
+        <p:spPr>
+          <a:xfrm>
+            <a:off x="4453128" y="2706624"/>
+            <a:ext cx="969264" cy="137160"/>
+          </a:xfrm>
+          <a:prstGeom prst="rect">
+            <a:avLst/>
+          </a:prstGeom>
+          <a:noFill/>
+        </p:spPr>
+        <p:txBody>
+          <a:bodyPr wrap="square" lIns="0" rIns="0" tIns="0" bIns="0">
+            <a:spAutoFit/>
+          </a:bodyPr>
+          <a:lstStyle/>
+          <a:p>
+            <a:pPr algn="ctr"/>
+            <a:r>
+              <a:rPr sz="900" b="1">
+                <a:solidFill>
+                  <a:srgbClr val="FFFFFF"/>
+                </a:solidFill>
+                <a:latin typeface="Aptos"/>
+              </a:rPr>
+              <a:t>18</a:t>
+            </a:r>
+          </a:p>
+        </p:txBody>
+      </p:sp>
+      <p:sp>
+        <p:nvSpPr>
+          <p:cNvPr id="41" name="Rounded Rectangle 40"/>
+          <p:cNvSpPr/>
+          <p:nvPr/>
+        </p:nvSpPr>
+        <p:spPr>
+          <a:xfrm>
+            <a:off x="6172200" y="1097280"/>
+            <a:ext cx="5394960" cy="1783080"/>
+          </a:xfrm>
+          <a:prstGeom prst="roundRect">
+            <a:avLst/>
+          </a:prstGeom>
+          <a:solidFill>
+            <a:srgbClr val="FFFFFF"/>
+          </a:solidFill>
+          <a:ln w="12700">
+            <a:solidFill>
+              <a:srgbClr val="DAE2EE"/>
+            </a:solidFill>
+          </a:ln>
+        </p:spPr>
+        <p:style>
+          <a:lnRef idx="1">
+            <a:schemeClr val="accent1"/>
+          </a:lnRef>
+          <a:fillRef idx="3">
+            <a:schemeClr val="accent1"/>
+          </a:fillRef>
+          <a:effectRef idx="2">
+            <a:schemeClr val="accent1"/>
+          </a:effectRef>
+          <a:fontRef idx="minor">
+            <a:schemeClr val="lt1"/>
+          </a:fontRef>
+        </p:style>
+        <p:txBody>
+          <a:bodyPr rtlCol="0" anchor="ctr"/>
+          <a:lstStyle/>
+          <a:p>
+            <a:pPr algn="ctr"/>
+          </a:p>
+        </p:txBody>
+      </p:sp>
+      <p:sp>
+        <p:nvSpPr>
+          <p:cNvPr id="42" name="Rectangle 41"/>
+          <p:cNvSpPr/>
+          <p:nvPr/>
+        </p:nvSpPr>
+        <p:spPr>
+          <a:xfrm>
+            <a:off x="6172200" y="1097280"/>
+            <a:ext cx="5394960" cy="73152"/>
+          </a:xfrm>
+          <a:prstGeom prst="rect">
+            <a:avLst/>
+          </a:prstGeom>
+          <a:solidFill>
+            <a:srgbClr val="028090"/>
+          </a:solidFill>
+          <a:ln>
+            <a:noFill/>
+          </a:ln>
+        </p:spPr>
+        <p:style>
+          <a:lnRef idx="1">
+            <a:schemeClr val="accent1"/>
+          </a:lnRef>
+          <a:fillRef idx="3">
+            <a:schemeClr val="accent1"/>
+          </a:fillRef>
+          <a:effectRef idx="2">
+            <a:schemeClr val="accent1"/>
+          </a:effectRef>
+          <a:fontRef idx="minor">
+            <a:schemeClr val="lt1"/>
+          </a:fontRef>
+        </p:style>
+        <p:txBody>
+          <a:bodyPr rtlCol="0" anchor="ctr"/>
+          <a:lstStyle/>
+          <a:p>
+            <a:pPr algn="ctr"/>
+          </a:p>
+        </p:txBody>
+      </p:sp>
+      <p:sp>
+        <p:nvSpPr>
+          <p:cNvPr id="43" name="TextBox 42"/>
+          <p:cNvSpPr txBox="1"/>
+          <p:nvPr/>
+        </p:nvSpPr>
+        <p:spPr>
+          <a:xfrm>
+            <a:off x="6309360" y="1225295"/>
+            <a:ext cx="5120640" cy="274320"/>
+          </a:xfrm>
+          <a:prstGeom prst="rect">
+            <a:avLst/>
+          </a:prstGeom>
+          <a:noFill/>
+        </p:spPr>
+        <p:txBody>
+          <a:bodyPr wrap="square" lIns="0" rIns="0" tIns="0" bIns="0">
+            <a:spAutoFit/>
+          </a:bodyPr>
+          <a:lstStyle/>
+          <a:p>
+            <a:r>
+              <a:rPr sz="1400" b="1">
+                <a:solidFill>
+                  <a:srgbClr val="1E2761"/>
+                </a:solidFill>
+                <a:latin typeface="Aptos"/>
+              </a:rPr>
+              <a:t>Support status by database type</a:t>
+            </a:r>
+          </a:p>
+        </p:txBody>
+      </p:sp>
+      <p:sp>
+        <p:nvSpPr>
+          <p:cNvPr id="44" name="Rounded Rectangle 43"/>
+          <p:cNvSpPr/>
+          <p:nvPr/>
+        </p:nvSpPr>
+        <p:spPr>
+          <a:xfrm>
+            <a:off x="7498079" y="1572768"/>
+            <a:ext cx="1197863" cy="228600"/>
+          </a:xfrm>
+          <a:prstGeom prst="roundRect">
+            <a:avLst/>
+          </a:prstGeom>
+          <a:solidFill>
+            <a:srgbClr val="228B22"/>
+          </a:solidFill>
+          <a:ln>
+            <a:noFill/>
+          </a:ln>
+        </p:spPr>
+        <p:style>
+          <a:lnRef idx="1">
+            <a:schemeClr val="accent1"/>
+          </a:lnRef>
+          <a:fillRef idx="3">
+            <a:schemeClr val="accent1"/>
+          </a:fillRef>
+          <a:effectRef idx="2">
+            <a:schemeClr val="accent1"/>
+          </a:effectRef>
+          <a:fontRef idx="minor">
+            <a:schemeClr val="lt1"/>
+          </a:fontRef>
+        </p:style>
+        <p:txBody>
+          <a:bodyPr rtlCol="0" anchor="ctr"/>
+          <a:lstStyle/>
+          <a:p>
+            <a:pPr algn="ctr"/>
+          </a:p>
+        </p:txBody>
+      </p:sp>
+      <p:sp>
+        <p:nvSpPr>
+          <p:cNvPr id="45" name="TextBox 44"/>
+          <p:cNvSpPr txBox="1"/>
+          <p:nvPr/>
+        </p:nvSpPr>
+        <p:spPr>
+          <a:xfrm>
+            <a:off x="7543800" y="1618488"/>
+            <a:ext cx="1106423" cy="146304"/>
+          </a:xfrm>
+          <a:prstGeom prst="rect">
+            <a:avLst/>
+          </a:prstGeom>
+          <a:noFill/>
+        </p:spPr>
+        <p:txBody>
+          <a:bodyPr wrap="square" lIns="0" rIns="0" tIns="0" bIns="0">
+            <a:spAutoFit/>
+          </a:bodyPr>
+          <a:lstStyle/>
+          <a:p>
+            <a:pPr algn="ctr"/>
+            <a:r>
+              <a:rPr sz="900" b="1">
+                <a:solidFill>
+                  <a:srgbClr val="FFFFFF"/>
+                </a:solidFill>
+                <a:latin typeface="Aptos"/>
+              </a:rPr>
+              <a:t>Mainstream</a:t>
+            </a:r>
+          </a:p>
+        </p:txBody>
+      </p:sp>
+      <p:sp>
+        <p:nvSpPr>
+          <p:cNvPr id="46" name="Rounded Rectangle 45"/>
+          <p:cNvSpPr/>
+          <p:nvPr/>
+        </p:nvSpPr>
+        <p:spPr>
+          <a:xfrm>
+            <a:off x="8732519" y="1572768"/>
+            <a:ext cx="1197863" cy="228600"/>
+          </a:xfrm>
+          <a:prstGeom prst="roundRect">
+            <a:avLst/>
+          </a:prstGeom>
+          <a:solidFill>
+            <a:srgbClr val="DC2626"/>
+          </a:solidFill>
+          <a:ln>
+            <a:noFill/>
+          </a:ln>
+        </p:spPr>
+        <p:style>
+          <a:lnRef idx="1">
+            <a:schemeClr val="accent1"/>
+          </a:lnRef>
+          <a:fillRef idx="3">
+            <a:schemeClr val="accent1"/>
+          </a:fillRef>
+          <a:effectRef idx="2">
+            <a:schemeClr val="accent1"/>
+          </a:effectRef>
+          <a:fontRef idx="minor">
+            <a:schemeClr val="lt1"/>
+          </a:fontRef>
+        </p:style>
+        <p:txBody>
+          <a:bodyPr rtlCol="0" anchor="ctr"/>
+          <a:lstStyle/>
+          <a:p>
+            <a:pPr algn="ctr"/>
+          </a:p>
+        </p:txBody>
+      </p:sp>
+      <p:sp>
+        <p:nvSpPr>
+          <p:cNvPr id="47" name="TextBox 46"/>
+          <p:cNvSpPr txBox="1"/>
+          <p:nvPr/>
+        </p:nvSpPr>
+        <p:spPr>
+          <a:xfrm>
+            <a:off x="8778240" y="1618488"/>
+            <a:ext cx="1106423" cy="146304"/>
+          </a:xfrm>
+          <a:prstGeom prst="rect">
+            <a:avLst/>
+          </a:prstGeom>
+          <a:noFill/>
+        </p:spPr>
+        <p:txBody>
+          <a:bodyPr wrap="square" lIns="0" rIns="0" tIns="0" bIns="0">
+            <a:spAutoFit/>
+          </a:bodyPr>
+          <a:lstStyle/>
+          <a:p>
+            <a:pPr algn="ctr"/>
+            <a:r>
+              <a:rPr sz="900" b="1">
+                <a:solidFill>
+                  <a:srgbClr val="FFFFFF"/>
+                </a:solidFill>
+                <a:latin typeface="Aptos"/>
+              </a:rPr>
+              <a:t>Out of support</a:t>
+            </a:r>
+          </a:p>
+        </p:txBody>
+      </p:sp>
+      <p:sp>
+        <p:nvSpPr>
+          <p:cNvPr id="48" name="Rounded Rectangle 47"/>
+          <p:cNvSpPr/>
+          <p:nvPr/>
+        </p:nvSpPr>
+        <p:spPr>
+          <a:xfrm>
+            <a:off x="9966959" y="1572768"/>
+            <a:ext cx="1197863" cy="228600"/>
           </a:xfrm>
           <a:prstGeom prst="roundRect">
             <a:avLst/>
@@ -15778,14 +17386,14 @@
       </p:sp>
       <p:sp>
         <p:nvSpPr>
-          <p:cNvPr id="8" name="TextBox 7"/>
+          <p:cNvPr id="49" name="TextBox 48"/>
           <p:cNvSpPr txBox="1"/>
           <p:nvPr/>
         </p:nvSpPr>
         <p:spPr>
           <a:xfrm>
-            <a:off x="2423160" y="2240280"/>
-            <a:ext cx="1874519" cy="228600"/>
+            <a:off x="10012680" y="1618488"/>
+            <a:ext cx="1106423" cy="146304"/>
           </a:xfrm>
           <a:prstGeom prst="rect">
             <a:avLst/>
@@ -15800,7 +17408,7 @@
           <a:p>
             <a:pPr algn="ctr"/>
             <a:r>
-              <a:rPr sz="1200" b="1">
+              <a:rPr sz="900" b="1">
                 <a:solidFill>
                   <a:srgbClr val="FFFFFF"/>
                 </a:solidFill>
@@ -15813,23 +17421,59 @@
       </p:sp>
       <p:sp>
         <p:nvSpPr>
-          <p:cNvPr id="9" name="Rounded Rectangle 8"/>
+          <p:cNvPr id="50" name="TextBox 49"/>
+          <p:cNvSpPr txBox="1"/>
+          <p:nvPr/>
+        </p:nvSpPr>
+        <p:spPr>
+          <a:xfrm>
+            <a:off x="6400800" y="1883664"/>
+            <a:ext cx="960120" cy="164592"/>
+          </a:xfrm>
+          <a:prstGeom prst="rect">
+            <a:avLst/>
+          </a:prstGeom>
+          <a:noFill/>
+        </p:spPr>
+        <p:txBody>
+          <a:bodyPr wrap="square" lIns="0" rIns="0" tIns="0" bIns="0">
+            <a:spAutoFit/>
+          </a:bodyPr>
+          <a:lstStyle/>
+          <a:p>
+            <a:r>
+              <a:rPr sz="1000" b="1">
+                <a:solidFill>
+                  <a:srgbClr val="1E2761"/>
+                </a:solidFill>
+                <a:latin typeface="Aptos"/>
+              </a:rPr>
+              <a:t>MongoDB</a:t>
+            </a:r>
+          </a:p>
+        </p:txBody>
+      </p:sp>
+      <p:sp>
+        <p:nvSpPr>
+          <p:cNvPr id="51" name="Rounded Rectangle 50"/>
           <p:cNvSpPr/>
           <p:nvPr/>
         </p:nvSpPr>
         <p:spPr>
           <a:xfrm>
-            <a:off x="4462272" y="2057400"/>
-            <a:ext cx="2057400" cy="658368"/>
+            <a:off x="7498079" y="1847088"/>
+            <a:ext cx="1197863" cy="228600"/>
           </a:xfrm>
           <a:prstGeom prst="roundRect">
             <a:avLst/>
           </a:prstGeom>
           <a:solidFill>
-            <a:srgbClr val="228B22"/>
+            <a:srgbClr val="CEE5CE"/>
           </a:solidFill>
-          <a:ln>
-            <a:noFill/>
+          <a:ln w="12700">
+            <a:solidFill>
+              <a:srgbClr val="FFFFFF"/>
+            </a:solidFill>
           </a:ln>
         </p:spPr>
         <p:style>
@@ -15856,14 +17500,14 @@
       </p:sp>
       <p:sp>
         <p:nvSpPr>
-          <p:cNvPr id="10" name="TextBox 9"/>
+          <p:cNvPr id="52" name="TextBox 51"/>
           <p:cNvSpPr txBox="1"/>
           <p:nvPr/>
         </p:nvSpPr>
         <p:spPr>
           <a:xfrm>
-            <a:off x="4553712" y="2240280"/>
-            <a:ext cx="1874519" cy="228600"/>
+            <a:off x="7543800" y="1883664"/>
+            <a:ext cx="1106423" cy="137160"/>
           </a:xfrm>
           <a:prstGeom prst="rect">
             <a:avLst/>
@@ -15878,36 +17522,38 @@
           <a:p>
             <a:pPr algn="ctr"/>
             <a:r>
-              <a:rPr sz="1200" b="1">
-                <a:solidFill>
-                  <a:srgbClr val="FFFFFF"/>
+              <a:rPr sz="900" b="1">
+                <a:solidFill>
+                  <a:srgbClr val="1E2761"/>
                 </a:solidFill>
                 <a:latin typeface="Aptos"/>
               </a:rPr>
-              <a:t>Ready</a:t>
-            </a:r>
-          </a:p>
-        </p:txBody>
-      </p:sp>
-      <p:sp>
-        <p:nvSpPr>
-          <p:cNvPr id="11" name="Rounded Rectangle 10"/>
+              <a:t>10</a:t>
+            </a:r>
+          </a:p>
+        </p:txBody>
+      </p:sp>
+      <p:sp>
+        <p:nvSpPr>
+          <p:cNvPr id="53" name="Rounded Rectangle 52"/>
           <p:cNvSpPr/>
           <p:nvPr/>
         </p:nvSpPr>
         <p:spPr>
           <a:xfrm>
-            <a:off x="6592824" y="2057400"/>
-            <a:ext cx="2057400" cy="658368"/>
+            <a:off x="8732519" y="1847088"/>
+            <a:ext cx="1197863" cy="228600"/>
           </a:xfrm>
           <a:prstGeom prst="roundRect">
             <a:avLst/>
           </a:prstGeom>
           <a:solidFill>
-            <a:srgbClr val="EAB308"/>
+            <a:srgbClr val="F7CFCF"/>
           </a:solidFill>
-          <a:ln>
-            <a:noFill/>
+          <a:ln w="12700">
+            <a:solidFill>
+              <a:srgbClr val="FFFFFF"/>
+            </a:solidFill>
           </a:ln>
         </p:spPr>
         <p:style>
@@ -15934,14 +17580,14 @@
       </p:sp>
       <p:sp>
         <p:nvSpPr>
-          <p:cNvPr id="12" name="TextBox 11"/>
+          <p:cNvPr id="54" name="TextBox 53"/>
           <p:cNvSpPr txBox="1"/>
           <p:nvPr/>
         </p:nvSpPr>
         <p:spPr>
           <a:xfrm>
-            <a:off x="6684264" y="2240280"/>
-            <a:ext cx="1874519" cy="228600"/>
+            <a:off x="8778240" y="1883664"/>
+            <a:ext cx="1106423" cy="137160"/>
           </a:xfrm>
           <a:prstGeom prst="rect">
             <a:avLst/>
@@ -15956,139 +17602,27 @@
           <a:p>
             <a:pPr algn="ctr"/>
             <a:r>
-              <a:rPr sz="1200" b="1">
+              <a:rPr sz="900" b="1">
                 <a:solidFill>
                   <a:srgbClr val="1E2761"/>
                 </a:solidFill>
                 <a:latin typeface="Aptos"/>
               </a:rPr>
-              <a:t>Ready w/ conditions</a:t>
-            </a:r>
-          </a:p>
-        </p:txBody>
-      </p:sp>
-      <p:sp>
-        <p:nvSpPr>
-          <p:cNvPr id="13" name="Rounded Rectangle 12"/>
+              <a:t>4</a:t>
+            </a:r>
+          </a:p>
+        </p:txBody>
+      </p:sp>
+      <p:sp>
+        <p:nvSpPr>
+          <p:cNvPr id="55" name="Rounded Rectangle 54"/>
           <p:cNvSpPr/>
           <p:nvPr/>
         </p:nvSpPr>
         <p:spPr>
           <a:xfrm>
-            <a:off x="8723376" y="2057400"/>
-            <a:ext cx="2057400" cy="658368"/>
-          </a:xfrm>
-          <a:prstGeom prst="roundRect">
-            <a:avLst/>
-          </a:prstGeom>
-          <a:solidFill>
-            <a:srgbClr val="DC2626"/>
-          </a:solidFill>
-          <a:ln>
-            <a:noFill/>
-          </a:ln>
-        </p:spPr>
-        <p:style>
-          <a:lnRef idx="1">
-            <a:schemeClr val="accent1"/>
-          </a:lnRef>
-          <a:fillRef idx="3">
-            <a:schemeClr val="accent1"/>
-          </a:fillRef>
-          <a:effectRef idx="2">
-            <a:schemeClr val="accent1"/>
-          </a:effectRef>
-          <a:fontRef idx="minor">
-            <a:schemeClr val="lt1"/>
-          </a:fontRef>
-        </p:style>
-        <p:txBody>
-          <a:bodyPr rtlCol="0" anchor="ctr"/>
-          <a:lstStyle/>
-          <a:p>
-            <a:pPr algn="ctr"/>
-          </a:p>
-        </p:txBody>
-      </p:sp>
-      <p:sp>
-        <p:nvSpPr>
-          <p:cNvPr id="14" name="TextBox 13"/>
-          <p:cNvSpPr txBox="1"/>
-          <p:nvPr/>
-        </p:nvSpPr>
-        <p:spPr>
-          <a:xfrm>
-            <a:off x="8814815" y="2240280"/>
-            <a:ext cx="1874519" cy="228600"/>
-          </a:xfrm>
-          <a:prstGeom prst="rect">
-            <a:avLst/>
-          </a:prstGeom>
-          <a:noFill/>
-        </p:spPr>
-        <p:txBody>
-          <a:bodyPr wrap="square" lIns="0" rIns="0" tIns="0" bIns="0">
-            <a:spAutoFit/>
-          </a:bodyPr>
-          <a:lstStyle/>
-          <a:p>
-            <a:pPr algn="ctr"/>
-            <a:r>
-              <a:rPr sz="1200" b="1">
-                <a:solidFill>
-                  <a:srgbClr val="FFFFFF"/>
-                </a:solidFill>
-                <a:latin typeface="Aptos"/>
-              </a:rPr>
-              <a:t>Not ready</a:t>
-            </a:r>
-          </a:p>
-        </p:txBody>
-      </p:sp>
-      <p:sp>
-        <p:nvSpPr>
-          <p:cNvPr id="15" name="TextBox 14"/>
-          <p:cNvSpPr txBox="1"/>
-          <p:nvPr/>
-        </p:nvSpPr>
-        <p:spPr>
-          <a:xfrm>
-            <a:off x="914400" y="2971800"/>
-            <a:ext cx="1143000" cy="228600"/>
-          </a:xfrm>
-          <a:prstGeom prst="rect">
-            <a:avLst/>
-          </a:prstGeom>
-          <a:noFill/>
-        </p:spPr>
-        <p:txBody>
-          <a:bodyPr wrap="square" lIns="0" rIns="0" tIns="0" bIns="0">
-            <a:spAutoFit/>
-          </a:bodyPr>
-          <a:lstStyle/>
-          <a:p>
-            <a:r>
-              <a:rPr sz="1200" b="1">
-                <a:solidFill>
-                  <a:srgbClr val="1E2761"/>
-                </a:solidFill>
-                <a:latin typeface="Aptos"/>
-              </a:rPr>
-              <a:t>MongoDB</a:t>
-            </a:r>
-          </a:p>
-        </p:txBody>
-      </p:sp>
-      <p:sp>
-        <p:nvSpPr>
-          <p:cNvPr id="16" name="Rounded Rectangle 15"/>
-          <p:cNvSpPr/>
-          <p:nvPr/>
-        </p:nvSpPr>
-        <p:spPr>
-          <a:xfrm>
-            <a:off x="2331720" y="2788920"/>
-            <a:ext cx="2057400" cy="658368"/>
+            <a:off x="9966959" y="1847088"/>
+            <a:ext cx="1197863" cy="228600"/>
           </a:xfrm>
           <a:prstGeom prst="roundRect">
             <a:avLst/>
@@ -16126,14 +17660,14 @@
       </p:sp>
       <p:sp>
         <p:nvSpPr>
-          <p:cNvPr id="17" name="TextBox 16"/>
+          <p:cNvPr id="56" name="TextBox 55"/>
           <p:cNvSpPr txBox="1"/>
           <p:nvPr/>
         </p:nvSpPr>
         <p:spPr>
           <a:xfrm>
-            <a:off x="2423160" y="2953512"/>
-            <a:ext cx="1874519" cy="256032"/>
+            <a:off x="10012680" y="1883664"/>
+            <a:ext cx="1106423" cy="137160"/>
           </a:xfrm>
           <a:prstGeom prst="rect">
             <a:avLst/>
@@ -16148,27 +17682,61 @@
           <a:p>
             <a:pPr algn="ctr"/>
             <a:r>
-              <a:rPr sz="1600" b="1">
+              <a:rPr sz="900" b="1">
                 <a:solidFill>
                   <a:srgbClr val="1E2761"/>
                 </a:solidFill>
                 <a:latin typeface="Aptos"/>
               </a:rPr>
-              <a:t>0</a:t>
-            </a:r>
-          </a:p>
-        </p:txBody>
-      </p:sp>
-      <p:sp>
-        <p:nvSpPr>
-          <p:cNvPr id="18" name="Rounded Rectangle 17"/>
+              <a:t>5</a:t>
+            </a:r>
+          </a:p>
+        </p:txBody>
+      </p:sp>
+      <p:sp>
+        <p:nvSpPr>
+          <p:cNvPr id="57" name="TextBox 56"/>
+          <p:cNvSpPr txBox="1"/>
+          <p:nvPr/>
+        </p:nvSpPr>
+        <p:spPr>
+          <a:xfrm>
+            <a:off x="6400800" y="2157984"/>
+            <a:ext cx="960120" cy="164592"/>
+          </a:xfrm>
+          <a:prstGeom prst="rect">
+            <a:avLst/>
+          </a:prstGeom>
+          <a:noFill/>
+        </p:spPr>
+        <p:txBody>
+          <a:bodyPr wrap="square" lIns="0" rIns="0" tIns="0" bIns="0">
+            <a:spAutoFit/>
+          </a:bodyPr>
+          <a:lstStyle/>
+          <a:p>
+            <a:r>
+              <a:rPr sz="1000" b="1">
+                <a:solidFill>
+                  <a:srgbClr val="1E2761"/>
+                </a:solidFill>
+                <a:latin typeface="Aptos"/>
+              </a:rPr>
+              <a:t>MySQL</a:t>
+            </a:r>
+          </a:p>
+        </p:txBody>
+      </p:sp>
+      <p:sp>
+        <p:nvSpPr>
+          <p:cNvPr id="58" name="Rounded Rectangle 57"/>
           <p:cNvSpPr/>
           <p:nvPr/>
         </p:nvSpPr>
         <p:spPr>
           <a:xfrm>
-            <a:off x="4462272" y="2788920"/>
-            <a:ext cx="2057400" cy="658368"/>
+            <a:off x="7498079" y="2121408"/>
+            <a:ext cx="1197863" cy="228600"/>
           </a:xfrm>
           <a:prstGeom prst="roundRect">
             <a:avLst/>
@@ -16206,14 +17774,14 @@
       </p:sp>
       <p:sp>
         <p:nvSpPr>
-          <p:cNvPr id="19" name="TextBox 18"/>
+          <p:cNvPr id="59" name="TextBox 58"/>
           <p:cNvSpPr txBox="1"/>
           <p:nvPr/>
         </p:nvSpPr>
         <p:spPr>
           <a:xfrm>
-            <a:off x="4553712" y="2953512"/>
-            <a:ext cx="1874519" cy="256032"/>
+            <a:off x="7543800" y="2157984"/>
+            <a:ext cx="1106423" cy="137160"/>
           </a:xfrm>
           <a:prstGeom prst="rect">
             <a:avLst/>
@@ -16228,7 +17796,1263 @@
           <a:p>
             <a:pPr algn="ctr"/>
             <a:r>
-              <a:rPr sz="1600" b="1">
+              <a:rPr sz="900" b="1">
+                <a:solidFill>
+                  <a:srgbClr val="1E2761"/>
+                </a:solidFill>
+                <a:latin typeface="Aptos"/>
+              </a:rPr>
+              <a:t>2</a:t>
+            </a:r>
+          </a:p>
+        </p:txBody>
+      </p:sp>
+      <p:sp>
+        <p:nvSpPr>
+          <p:cNvPr id="60" name="Rounded Rectangle 59"/>
+          <p:cNvSpPr/>
+          <p:nvPr/>
+        </p:nvSpPr>
+        <p:spPr>
+          <a:xfrm>
+            <a:off x="8732519" y="2121408"/>
+            <a:ext cx="1197863" cy="228600"/>
+          </a:xfrm>
+          <a:prstGeom prst="roundRect">
+            <a:avLst/>
+          </a:prstGeom>
+          <a:solidFill>
+            <a:srgbClr val="F7CFCF"/>
+          </a:solidFill>
+          <a:ln w="12700">
+            <a:solidFill>
+              <a:srgbClr val="FFFFFF"/>
+            </a:solidFill>
+          </a:ln>
+        </p:spPr>
+        <p:style>
+          <a:lnRef idx="1">
+            <a:schemeClr val="accent1"/>
+          </a:lnRef>
+          <a:fillRef idx="3">
+            <a:schemeClr val="accent1"/>
+          </a:fillRef>
+          <a:effectRef idx="2">
+            <a:schemeClr val="accent1"/>
+          </a:effectRef>
+          <a:fontRef idx="minor">
+            <a:schemeClr val="lt1"/>
+          </a:fontRef>
+        </p:style>
+        <p:txBody>
+          <a:bodyPr rtlCol="0" anchor="ctr"/>
+          <a:lstStyle/>
+          <a:p>
+            <a:pPr algn="ctr"/>
+          </a:p>
+        </p:txBody>
+      </p:sp>
+      <p:sp>
+        <p:nvSpPr>
+          <p:cNvPr id="61" name="TextBox 60"/>
+          <p:cNvSpPr txBox="1"/>
+          <p:nvPr/>
+        </p:nvSpPr>
+        <p:spPr>
+          <a:xfrm>
+            <a:off x="8778240" y="2157984"/>
+            <a:ext cx="1106423" cy="137160"/>
+          </a:xfrm>
+          <a:prstGeom prst="rect">
+            <a:avLst/>
+          </a:prstGeom>
+          <a:noFill/>
+        </p:spPr>
+        <p:txBody>
+          <a:bodyPr wrap="square" lIns="0" rIns="0" tIns="0" bIns="0">
+            <a:spAutoFit/>
+          </a:bodyPr>
+          <a:lstStyle/>
+          <a:p>
+            <a:pPr algn="ctr"/>
+            <a:r>
+              <a:rPr sz="900" b="1">
+                <a:solidFill>
+                  <a:srgbClr val="1E2761"/>
+                </a:solidFill>
+                <a:latin typeface="Aptos"/>
+              </a:rPr>
+              <a:t>8</a:t>
+            </a:r>
+          </a:p>
+        </p:txBody>
+      </p:sp>
+      <p:sp>
+        <p:nvSpPr>
+          <p:cNvPr id="62" name="Rounded Rectangle 61"/>
+          <p:cNvSpPr/>
+          <p:nvPr/>
+        </p:nvSpPr>
+        <p:spPr>
+          <a:xfrm>
+            <a:off x="9966959" y="2121408"/>
+            <a:ext cx="1197863" cy="228600"/>
+          </a:xfrm>
+          <a:prstGeom prst="roundRect">
+            <a:avLst/>
+          </a:prstGeom>
+          <a:solidFill>
+            <a:srgbClr val="E7EAEF"/>
+          </a:solidFill>
+          <a:ln w="12700">
+            <a:solidFill>
+              <a:srgbClr val="FFFFFF"/>
+            </a:solidFill>
+          </a:ln>
+        </p:spPr>
+        <p:style>
+          <a:lnRef idx="1">
+            <a:schemeClr val="accent1"/>
+          </a:lnRef>
+          <a:fillRef idx="3">
+            <a:schemeClr val="accent1"/>
+          </a:fillRef>
+          <a:effectRef idx="2">
+            <a:schemeClr val="accent1"/>
+          </a:effectRef>
+          <a:fontRef idx="minor">
+            <a:schemeClr val="lt1"/>
+          </a:fontRef>
+        </p:style>
+        <p:txBody>
+          <a:bodyPr rtlCol="0" anchor="ctr"/>
+          <a:lstStyle/>
+          <a:p>
+            <a:pPr algn="ctr"/>
+          </a:p>
+        </p:txBody>
+      </p:sp>
+      <p:sp>
+        <p:nvSpPr>
+          <p:cNvPr id="63" name="TextBox 62"/>
+          <p:cNvSpPr txBox="1"/>
+          <p:nvPr/>
+        </p:nvSpPr>
+        <p:spPr>
+          <a:xfrm>
+            <a:off x="10012680" y="2157984"/>
+            <a:ext cx="1106423" cy="137160"/>
+          </a:xfrm>
+          <a:prstGeom prst="rect">
+            <a:avLst/>
+          </a:prstGeom>
+          <a:noFill/>
+        </p:spPr>
+        <p:txBody>
+          <a:bodyPr wrap="square" lIns="0" rIns="0" tIns="0" bIns="0">
+            <a:spAutoFit/>
+          </a:bodyPr>
+          <a:lstStyle/>
+          <a:p>
+            <a:pPr algn="ctr"/>
+            <a:r>
+              <a:rPr sz="900" b="1">
+                <a:solidFill>
+                  <a:srgbClr val="1E2761"/>
+                </a:solidFill>
+                <a:latin typeface="Aptos"/>
+              </a:rPr>
+              <a:t>1</a:t>
+            </a:r>
+          </a:p>
+        </p:txBody>
+      </p:sp>
+      <p:sp>
+        <p:nvSpPr>
+          <p:cNvPr id="64" name="TextBox 63"/>
+          <p:cNvSpPr txBox="1"/>
+          <p:nvPr/>
+        </p:nvSpPr>
+        <p:spPr>
+          <a:xfrm>
+            <a:off x="6400800" y="2432304"/>
+            <a:ext cx="960120" cy="164592"/>
+          </a:xfrm>
+          <a:prstGeom prst="rect">
+            <a:avLst/>
+          </a:prstGeom>
+          <a:noFill/>
+        </p:spPr>
+        <p:txBody>
+          <a:bodyPr wrap="square" lIns="0" rIns="0" tIns="0" bIns="0">
+            <a:spAutoFit/>
+          </a:bodyPr>
+          <a:lstStyle/>
+          <a:p>
+            <a:r>
+              <a:rPr sz="1000" b="1">
+                <a:solidFill>
+                  <a:srgbClr val="1E2761"/>
+                </a:solidFill>
+                <a:latin typeface="Aptos"/>
+              </a:rPr>
+              <a:t>PostgreSQL</a:t>
+            </a:r>
+          </a:p>
+        </p:txBody>
+      </p:sp>
+      <p:sp>
+        <p:nvSpPr>
+          <p:cNvPr id="65" name="Rounded Rectangle 64"/>
+          <p:cNvSpPr/>
+          <p:nvPr/>
+        </p:nvSpPr>
+        <p:spPr>
+          <a:xfrm>
+            <a:off x="7498079" y="2395728"/>
+            <a:ext cx="1197863" cy="228600"/>
+          </a:xfrm>
+          <a:prstGeom prst="roundRect">
+            <a:avLst/>
+          </a:prstGeom>
+          <a:solidFill>
+            <a:srgbClr val="CEE5CE"/>
+          </a:solidFill>
+          <a:ln w="12700">
+            <a:solidFill>
+              <a:srgbClr val="FFFFFF"/>
+            </a:solidFill>
+          </a:ln>
+        </p:spPr>
+        <p:style>
+          <a:lnRef idx="1">
+            <a:schemeClr val="accent1"/>
+          </a:lnRef>
+          <a:fillRef idx="3">
+            <a:schemeClr val="accent1"/>
+          </a:fillRef>
+          <a:effectRef idx="2">
+            <a:schemeClr val="accent1"/>
+          </a:effectRef>
+          <a:fontRef idx="minor">
+            <a:schemeClr val="lt1"/>
+          </a:fontRef>
+        </p:style>
+        <p:txBody>
+          <a:bodyPr rtlCol="0" anchor="ctr"/>
+          <a:lstStyle/>
+          <a:p>
+            <a:pPr algn="ctr"/>
+          </a:p>
+        </p:txBody>
+      </p:sp>
+      <p:sp>
+        <p:nvSpPr>
+          <p:cNvPr id="66" name="TextBox 65"/>
+          <p:cNvSpPr txBox="1"/>
+          <p:nvPr/>
+        </p:nvSpPr>
+        <p:spPr>
+          <a:xfrm>
+            <a:off x="7543800" y="2432304"/>
+            <a:ext cx="1106423" cy="137160"/>
+          </a:xfrm>
+          <a:prstGeom prst="rect">
+            <a:avLst/>
+          </a:prstGeom>
+          <a:noFill/>
+        </p:spPr>
+        <p:txBody>
+          <a:bodyPr wrap="square" lIns="0" rIns="0" tIns="0" bIns="0">
+            <a:spAutoFit/>
+          </a:bodyPr>
+          <a:lstStyle/>
+          <a:p>
+            <a:pPr algn="ctr"/>
+            <a:r>
+              <a:rPr sz="900" b="1">
+                <a:solidFill>
+                  <a:srgbClr val="1E2761"/>
+                </a:solidFill>
+                <a:latin typeface="Aptos"/>
+              </a:rPr>
+              <a:t>2</a:t>
+            </a:r>
+          </a:p>
+        </p:txBody>
+      </p:sp>
+      <p:sp>
+        <p:nvSpPr>
+          <p:cNvPr id="67" name="Rounded Rectangle 66"/>
+          <p:cNvSpPr/>
+          <p:nvPr/>
+        </p:nvSpPr>
+        <p:spPr>
+          <a:xfrm>
+            <a:off x="8732519" y="2395728"/>
+            <a:ext cx="1197863" cy="228600"/>
+          </a:xfrm>
+          <a:prstGeom prst="roundRect">
+            <a:avLst/>
+          </a:prstGeom>
+          <a:solidFill>
+            <a:srgbClr val="F7CFCF"/>
+          </a:solidFill>
+          <a:ln w="12700">
+            <a:solidFill>
+              <a:srgbClr val="FFFFFF"/>
+            </a:solidFill>
+          </a:ln>
+        </p:spPr>
+        <p:style>
+          <a:lnRef idx="1">
+            <a:schemeClr val="accent1"/>
+          </a:lnRef>
+          <a:fillRef idx="3">
+            <a:schemeClr val="accent1"/>
+          </a:fillRef>
+          <a:effectRef idx="2">
+            <a:schemeClr val="accent1"/>
+          </a:effectRef>
+          <a:fontRef idx="minor">
+            <a:schemeClr val="lt1"/>
+          </a:fontRef>
+        </p:style>
+        <p:txBody>
+          <a:bodyPr rtlCol="0" anchor="ctr"/>
+          <a:lstStyle/>
+          <a:p>
+            <a:pPr algn="ctr"/>
+          </a:p>
+        </p:txBody>
+      </p:sp>
+      <p:sp>
+        <p:nvSpPr>
+          <p:cNvPr id="68" name="TextBox 67"/>
+          <p:cNvSpPr txBox="1"/>
+          <p:nvPr/>
+        </p:nvSpPr>
+        <p:spPr>
+          <a:xfrm>
+            <a:off x="8778240" y="2432304"/>
+            <a:ext cx="1106423" cy="137160"/>
+          </a:xfrm>
+          <a:prstGeom prst="rect">
+            <a:avLst/>
+          </a:prstGeom>
+          <a:noFill/>
+        </p:spPr>
+        <p:txBody>
+          <a:bodyPr wrap="square" lIns="0" rIns="0" tIns="0" bIns="0">
+            <a:spAutoFit/>
+          </a:bodyPr>
+          <a:lstStyle/>
+          <a:p>
+            <a:pPr algn="ctr"/>
+            <a:r>
+              <a:rPr sz="900" b="1">
+                <a:solidFill>
+                  <a:srgbClr val="1E2761"/>
+                </a:solidFill>
+                <a:latin typeface="Aptos"/>
+              </a:rPr>
+              <a:t>2</a:t>
+            </a:r>
+          </a:p>
+        </p:txBody>
+      </p:sp>
+      <p:sp>
+        <p:nvSpPr>
+          <p:cNvPr id="69" name="Rounded Rectangle 68"/>
+          <p:cNvSpPr/>
+          <p:nvPr/>
+        </p:nvSpPr>
+        <p:spPr>
+          <a:xfrm>
+            <a:off x="9966959" y="2395728"/>
+            <a:ext cx="1197863" cy="228600"/>
+          </a:xfrm>
+          <a:prstGeom prst="roundRect">
+            <a:avLst/>
+          </a:prstGeom>
+          <a:solidFill>
+            <a:srgbClr val="E7EAEF"/>
+          </a:solidFill>
+          <a:ln w="12700">
+            <a:solidFill>
+              <a:srgbClr val="FFFFFF"/>
+            </a:solidFill>
+          </a:ln>
+        </p:spPr>
+        <p:style>
+          <a:lnRef idx="1">
+            <a:schemeClr val="accent1"/>
+          </a:lnRef>
+          <a:fillRef idx="3">
+            <a:schemeClr val="accent1"/>
+          </a:fillRef>
+          <a:effectRef idx="2">
+            <a:schemeClr val="accent1"/>
+          </a:effectRef>
+          <a:fontRef idx="minor">
+            <a:schemeClr val="lt1"/>
+          </a:fontRef>
+        </p:style>
+        <p:txBody>
+          <a:bodyPr rtlCol="0" anchor="ctr"/>
+          <a:lstStyle/>
+          <a:p>
+            <a:pPr algn="ctr"/>
+          </a:p>
+        </p:txBody>
+      </p:sp>
+      <p:sp>
+        <p:nvSpPr>
+          <p:cNvPr id="70" name="TextBox 69"/>
+          <p:cNvSpPr txBox="1"/>
+          <p:nvPr/>
+        </p:nvSpPr>
+        <p:spPr>
+          <a:xfrm>
+            <a:off x="10012680" y="2432304"/>
+            <a:ext cx="1106423" cy="137160"/>
+          </a:xfrm>
+          <a:prstGeom prst="rect">
+            <a:avLst/>
+          </a:prstGeom>
+          <a:noFill/>
+        </p:spPr>
+        <p:txBody>
+          <a:bodyPr wrap="square" lIns="0" rIns="0" tIns="0" bIns="0">
+            <a:spAutoFit/>
+          </a:bodyPr>
+          <a:lstStyle/>
+          <a:p>
+            <a:pPr algn="ctr"/>
+            <a:r>
+              <a:rPr sz="900" b="1">
+                <a:solidFill>
+                  <a:srgbClr val="1E2761"/>
+                </a:solidFill>
+                <a:latin typeface="Aptos"/>
+              </a:rPr>
+              <a:t>3</a:t>
+            </a:r>
+          </a:p>
+        </p:txBody>
+      </p:sp>
+      <p:sp>
+        <p:nvSpPr>
+          <p:cNvPr id="71" name="TextBox 70"/>
+          <p:cNvSpPr txBox="1"/>
+          <p:nvPr/>
+        </p:nvSpPr>
+        <p:spPr>
+          <a:xfrm>
+            <a:off x="6400800" y="2706624"/>
+            <a:ext cx="960120" cy="164592"/>
+          </a:xfrm>
+          <a:prstGeom prst="rect">
+            <a:avLst/>
+          </a:prstGeom>
+          <a:noFill/>
+        </p:spPr>
+        <p:txBody>
+          <a:bodyPr wrap="square" lIns="0" rIns="0" tIns="0" bIns="0">
+            <a:spAutoFit/>
+          </a:bodyPr>
+          <a:lstStyle/>
+          <a:p>
+            <a:r>
+              <a:rPr sz="1000" b="1">
+                <a:solidFill>
+                  <a:srgbClr val="1E2761"/>
+                </a:solidFill>
+                <a:latin typeface="Aptos"/>
+              </a:rPr>
+              <a:t>Total</a:t>
+            </a:r>
+          </a:p>
+        </p:txBody>
+      </p:sp>
+      <p:sp>
+        <p:nvSpPr>
+          <p:cNvPr id="72" name="Rounded Rectangle 71"/>
+          <p:cNvSpPr/>
+          <p:nvPr/>
+        </p:nvSpPr>
+        <p:spPr>
+          <a:xfrm>
+            <a:off x="7498079" y="2670048"/>
+            <a:ext cx="1197863" cy="228600"/>
+          </a:xfrm>
+          <a:prstGeom prst="roundRect">
+            <a:avLst/>
+          </a:prstGeom>
+          <a:solidFill>
+            <a:srgbClr val="228B22"/>
+          </a:solidFill>
+          <a:ln w="12700">
+            <a:solidFill>
+              <a:srgbClr val="FFFFFF"/>
+            </a:solidFill>
+          </a:ln>
+        </p:spPr>
+        <p:style>
+          <a:lnRef idx="1">
+            <a:schemeClr val="accent1"/>
+          </a:lnRef>
+          <a:fillRef idx="3">
+            <a:schemeClr val="accent1"/>
+          </a:fillRef>
+          <a:effectRef idx="2">
+            <a:schemeClr val="accent1"/>
+          </a:effectRef>
+          <a:fontRef idx="minor">
+            <a:schemeClr val="lt1"/>
+          </a:fontRef>
+        </p:style>
+        <p:txBody>
+          <a:bodyPr rtlCol="0" anchor="ctr"/>
+          <a:lstStyle/>
+          <a:p>
+            <a:pPr algn="ctr"/>
+          </a:p>
+        </p:txBody>
+      </p:sp>
+      <p:sp>
+        <p:nvSpPr>
+          <p:cNvPr id="73" name="TextBox 72"/>
+          <p:cNvSpPr txBox="1"/>
+          <p:nvPr/>
+        </p:nvSpPr>
+        <p:spPr>
+          <a:xfrm>
+            <a:off x="7543800" y="2706624"/>
+            <a:ext cx="1106423" cy="137160"/>
+          </a:xfrm>
+          <a:prstGeom prst="rect">
+            <a:avLst/>
+          </a:prstGeom>
+          <a:noFill/>
+        </p:spPr>
+        <p:txBody>
+          <a:bodyPr wrap="square" lIns="0" rIns="0" tIns="0" bIns="0">
+            <a:spAutoFit/>
+          </a:bodyPr>
+          <a:lstStyle/>
+          <a:p>
+            <a:pPr algn="ctr"/>
+            <a:r>
+              <a:rPr sz="900" b="1">
+                <a:solidFill>
+                  <a:srgbClr val="FFFFFF"/>
+                </a:solidFill>
+                <a:latin typeface="Aptos"/>
+              </a:rPr>
+              <a:t>14</a:t>
+            </a:r>
+          </a:p>
+        </p:txBody>
+      </p:sp>
+      <p:sp>
+        <p:nvSpPr>
+          <p:cNvPr id="74" name="Rounded Rectangle 73"/>
+          <p:cNvSpPr/>
+          <p:nvPr/>
+        </p:nvSpPr>
+        <p:spPr>
+          <a:xfrm>
+            <a:off x="8732519" y="2670048"/>
+            <a:ext cx="1197863" cy="228600"/>
+          </a:xfrm>
+          <a:prstGeom prst="roundRect">
+            <a:avLst/>
+          </a:prstGeom>
+          <a:solidFill>
+            <a:srgbClr val="DC2626"/>
+          </a:solidFill>
+          <a:ln w="12700">
+            <a:solidFill>
+              <a:srgbClr val="FFFFFF"/>
+            </a:solidFill>
+          </a:ln>
+        </p:spPr>
+        <p:style>
+          <a:lnRef idx="1">
+            <a:schemeClr val="accent1"/>
+          </a:lnRef>
+          <a:fillRef idx="3">
+            <a:schemeClr val="accent1"/>
+          </a:fillRef>
+          <a:effectRef idx="2">
+            <a:schemeClr val="accent1"/>
+          </a:effectRef>
+          <a:fontRef idx="minor">
+            <a:schemeClr val="lt1"/>
+          </a:fontRef>
+        </p:style>
+        <p:txBody>
+          <a:bodyPr rtlCol="0" anchor="ctr"/>
+          <a:lstStyle/>
+          <a:p>
+            <a:pPr algn="ctr"/>
+          </a:p>
+        </p:txBody>
+      </p:sp>
+      <p:sp>
+        <p:nvSpPr>
+          <p:cNvPr id="75" name="TextBox 74"/>
+          <p:cNvSpPr txBox="1"/>
+          <p:nvPr/>
+        </p:nvSpPr>
+        <p:spPr>
+          <a:xfrm>
+            <a:off x="8778240" y="2706624"/>
+            <a:ext cx="1106423" cy="137160"/>
+          </a:xfrm>
+          <a:prstGeom prst="rect">
+            <a:avLst/>
+          </a:prstGeom>
+          <a:noFill/>
+        </p:spPr>
+        <p:txBody>
+          <a:bodyPr wrap="square" lIns="0" rIns="0" tIns="0" bIns="0">
+            <a:spAutoFit/>
+          </a:bodyPr>
+          <a:lstStyle/>
+          <a:p>
+            <a:pPr algn="ctr"/>
+            <a:r>
+              <a:rPr sz="900" b="1">
+                <a:solidFill>
+                  <a:srgbClr val="FFFFFF"/>
+                </a:solidFill>
+                <a:latin typeface="Aptos"/>
+              </a:rPr>
+              <a:t>14</a:t>
+            </a:r>
+          </a:p>
+        </p:txBody>
+      </p:sp>
+      <p:sp>
+        <p:nvSpPr>
+          <p:cNvPr id="76" name="Rounded Rectangle 75"/>
+          <p:cNvSpPr/>
+          <p:nvPr/>
+        </p:nvSpPr>
+        <p:spPr>
+          <a:xfrm>
+            <a:off x="9966959" y="2670048"/>
+            <a:ext cx="1197863" cy="228600"/>
+          </a:xfrm>
+          <a:prstGeom prst="roundRect">
+            <a:avLst/>
+          </a:prstGeom>
+          <a:solidFill>
+            <a:srgbClr val="94A3B8"/>
+          </a:solidFill>
+          <a:ln w="12700">
+            <a:solidFill>
+              <a:srgbClr val="FFFFFF"/>
+            </a:solidFill>
+          </a:ln>
+        </p:spPr>
+        <p:style>
+          <a:lnRef idx="1">
+            <a:schemeClr val="accent1"/>
+          </a:lnRef>
+          <a:fillRef idx="3">
+            <a:schemeClr val="accent1"/>
+          </a:fillRef>
+          <a:effectRef idx="2">
+            <a:schemeClr val="accent1"/>
+          </a:effectRef>
+          <a:fontRef idx="minor">
+            <a:schemeClr val="lt1"/>
+          </a:fontRef>
+        </p:style>
+        <p:txBody>
+          <a:bodyPr rtlCol="0" anchor="ctr"/>
+          <a:lstStyle/>
+          <a:p>
+            <a:pPr algn="ctr"/>
+          </a:p>
+        </p:txBody>
+      </p:sp>
+      <p:sp>
+        <p:nvSpPr>
+          <p:cNvPr id="77" name="TextBox 76"/>
+          <p:cNvSpPr txBox="1"/>
+          <p:nvPr/>
+        </p:nvSpPr>
+        <p:spPr>
+          <a:xfrm>
+            <a:off x="10012680" y="2706624"/>
+            <a:ext cx="1106423" cy="137160"/>
+          </a:xfrm>
+          <a:prstGeom prst="rect">
+            <a:avLst/>
+          </a:prstGeom>
+          <a:noFill/>
+        </p:spPr>
+        <p:txBody>
+          <a:bodyPr wrap="square" lIns="0" rIns="0" tIns="0" bIns="0">
+            <a:spAutoFit/>
+          </a:bodyPr>
+          <a:lstStyle/>
+          <a:p>
+            <a:pPr algn="ctr"/>
+            <a:r>
+              <a:rPr sz="900" b="1">
+                <a:solidFill>
+                  <a:srgbClr val="FFFFFF"/>
+                </a:solidFill>
+                <a:latin typeface="Aptos"/>
+              </a:rPr>
+              <a:t>9</a:t>
+            </a:r>
+          </a:p>
+        </p:txBody>
+      </p:sp>
+      <p:sp>
+        <p:nvSpPr>
+          <p:cNvPr id="78" name="Rounded Rectangle 77"/>
+          <p:cNvSpPr/>
+          <p:nvPr/>
+        </p:nvSpPr>
+        <p:spPr>
+          <a:xfrm>
+            <a:off x="594360" y="3154680"/>
+            <a:ext cx="10972800" cy="2788920"/>
+          </a:xfrm>
+          <a:prstGeom prst="roundRect">
+            <a:avLst/>
+          </a:prstGeom>
+          <a:solidFill>
+            <a:srgbClr val="FFFFFF"/>
+          </a:solidFill>
+          <a:ln w="12700">
+            <a:solidFill>
+              <a:srgbClr val="DAE2EE"/>
+            </a:solidFill>
+          </a:ln>
+        </p:spPr>
+        <p:style>
+          <a:lnRef idx="1">
+            <a:schemeClr val="accent1"/>
+          </a:lnRef>
+          <a:fillRef idx="3">
+            <a:schemeClr val="accent1"/>
+          </a:fillRef>
+          <a:effectRef idx="2">
+            <a:schemeClr val="accent1"/>
+          </a:effectRef>
+          <a:fontRef idx="minor">
+            <a:schemeClr val="lt1"/>
+          </a:fontRef>
+        </p:style>
+        <p:txBody>
+          <a:bodyPr rtlCol="0" anchor="ctr"/>
+          <a:lstStyle/>
+          <a:p>
+            <a:pPr algn="ctr"/>
+          </a:p>
+        </p:txBody>
+      </p:sp>
+      <p:sp>
+        <p:nvSpPr>
+          <p:cNvPr id="79" name="Rectangle 78"/>
+          <p:cNvSpPr/>
+          <p:nvPr/>
+        </p:nvSpPr>
+        <p:spPr>
+          <a:xfrm>
+            <a:off x="594360" y="3154680"/>
+            <a:ext cx="10972800" cy="73152"/>
+          </a:xfrm>
+          <a:prstGeom prst="rect">
+            <a:avLst/>
+          </a:prstGeom>
+          <a:solidFill>
+            <a:srgbClr val="028090"/>
+          </a:solidFill>
+          <a:ln>
+            <a:noFill/>
+          </a:ln>
+        </p:spPr>
+        <p:style>
+          <a:lnRef idx="1">
+            <a:schemeClr val="accent1"/>
+          </a:lnRef>
+          <a:fillRef idx="3">
+            <a:schemeClr val="accent1"/>
+          </a:fillRef>
+          <a:effectRef idx="2">
+            <a:schemeClr val="accent1"/>
+          </a:effectRef>
+          <a:fontRef idx="minor">
+            <a:schemeClr val="lt1"/>
+          </a:fontRef>
+        </p:style>
+        <p:txBody>
+          <a:bodyPr rtlCol="0" anchor="ctr"/>
+          <a:lstStyle/>
+          <a:p>
+            <a:pPr algn="ctr"/>
+          </a:p>
+        </p:txBody>
+      </p:sp>
+      <p:sp>
+        <p:nvSpPr>
+          <p:cNvPr id="80" name="TextBox 79"/>
+          <p:cNvSpPr txBox="1"/>
+          <p:nvPr/>
+        </p:nvSpPr>
+        <p:spPr>
+          <a:xfrm>
+            <a:off x="731520" y="3282696"/>
+            <a:ext cx="10698480" cy="274320"/>
+          </a:xfrm>
+          <a:prstGeom prst="rect">
+            <a:avLst/>
+          </a:prstGeom>
+          <a:noFill/>
+        </p:spPr>
+        <p:txBody>
+          <a:bodyPr wrap="square" lIns="0" rIns="0" tIns="0" bIns="0">
+            <a:spAutoFit/>
+          </a:bodyPr>
+          <a:lstStyle/>
+          <a:p>
+            <a:r>
+              <a:rPr sz="1400" b="1">
+                <a:solidFill>
+                  <a:srgbClr val="1E2761"/>
+                </a:solidFill>
+                <a:latin typeface="Aptos"/>
+              </a:rPr>
+              <a:t>PaaS readiness by database type</a:t>
+            </a:r>
+          </a:p>
+        </p:txBody>
+      </p:sp>
+      <p:sp>
+        <p:nvSpPr>
+          <p:cNvPr id="81" name="Rounded Rectangle 80"/>
+          <p:cNvSpPr/>
+          <p:nvPr/>
+        </p:nvSpPr>
+        <p:spPr>
+          <a:xfrm>
+            <a:off x="2148840" y="3675887"/>
+            <a:ext cx="2057400" cy="384048"/>
+          </a:xfrm>
+          <a:prstGeom prst="roundRect">
+            <a:avLst/>
+          </a:prstGeom>
+          <a:solidFill>
+            <a:srgbClr val="94A3B8"/>
+          </a:solidFill>
+          <a:ln>
+            <a:noFill/>
+          </a:ln>
+        </p:spPr>
+        <p:style>
+          <a:lnRef idx="1">
+            <a:schemeClr val="accent1"/>
+          </a:lnRef>
+          <a:fillRef idx="3">
+            <a:schemeClr val="accent1"/>
+          </a:fillRef>
+          <a:effectRef idx="2">
+            <a:schemeClr val="accent1"/>
+          </a:effectRef>
+          <a:fontRef idx="minor">
+            <a:schemeClr val="lt1"/>
+          </a:fontRef>
+        </p:style>
+        <p:txBody>
+          <a:bodyPr rtlCol="0" anchor="ctr"/>
+          <a:lstStyle/>
+          <a:p>
+            <a:pPr algn="ctr"/>
+          </a:p>
+        </p:txBody>
+      </p:sp>
+      <p:sp>
+        <p:nvSpPr>
+          <p:cNvPr id="82" name="TextBox 81"/>
+          <p:cNvSpPr txBox="1"/>
+          <p:nvPr/>
+        </p:nvSpPr>
+        <p:spPr>
+          <a:xfrm>
+            <a:off x="2240280" y="3749039"/>
+            <a:ext cx="1874519" cy="219456"/>
+          </a:xfrm>
+          <a:prstGeom prst="rect">
+            <a:avLst/>
+          </a:prstGeom>
+          <a:noFill/>
+        </p:spPr>
+        <p:txBody>
+          <a:bodyPr wrap="square" lIns="0" rIns="0" tIns="0" bIns="0">
+            <a:spAutoFit/>
+          </a:bodyPr>
+          <a:lstStyle/>
+          <a:p>
+            <a:pPr algn="ctr"/>
+            <a:r>
+              <a:rPr sz="1200" b="1">
+                <a:solidFill>
+                  <a:srgbClr val="FFFFFF"/>
+                </a:solidFill>
+                <a:latin typeface="Aptos"/>
+              </a:rPr>
+              <a:t>Unknown</a:t>
+            </a:r>
+          </a:p>
+        </p:txBody>
+      </p:sp>
+      <p:sp>
+        <p:nvSpPr>
+          <p:cNvPr id="83" name="Rounded Rectangle 82"/>
+          <p:cNvSpPr/>
+          <p:nvPr/>
+        </p:nvSpPr>
+        <p:spPr>
+          <a:xfrm>
+            <a:off x="4279392" y="3675887"/>
+            <a:ext cx="2057400" cy="384048"/>
+          </a:xfrm>
+          <a:prstGeom prst="roundRect">
+            <a:avLst/>
+          </a:prstGeom>
+          <a:solidFill>
+            <a:srgbClr val="228B22"/>
+          </a:solidFill>
+          <a:ln>
+            <a:noFill/>
+          </a:ln>
+        </p:spPr>
+        <p:style>
+          <a:lnRef idx="1">
+            <a:schemeClr val="accent1"/>
+          </a:lnRef>
+          <a:fillRef idx="3">
+            <a:schemeClr val="accent1"/>
+          </a:fillRef>
+          <a:effectRef idx="2">
+            <a:schemeClr val="accent1"/>
+          </a:effectRef>
+          <a:fontRef idx="minor">
+            <a:schemeClr val="lt1"/>
+          </a:fontRef>
+        </p:style>
+        <p:txBody>
+          <a:bodyPr rtlCol="0" anchor="ctr"/>
+          <a:lstStyle/>
+          <a:p>
+            <a:pPr algn="ctr"/>
+          </a:p>
+        </p:txBody>
+      </p:sp>
+      <p:sp>
+        <p:nvSpPr>
+          <p:cNvPr id="84" name="TextBox 83"/>
+          <p:cNvSpPr txBox="1"/>
+          <p:nvPr/>
+        </p:nvSpPr>
+        <p:spPr>
+          <a:xfrm>
+            <a:off x="4370831" y="3749039"/>
+            <a:ext cx="1874519" cy="219456"/>
+          </a:xfrm>
+          <a:prstGeom prst="rect">
+            <a:avLst/>
+          </a:prstGeom>
+          <a:noFill/>
+        </p:spPr>
+        <p:txBody>
+          <a:bodyPr wrap="square" lIns="0" rIns="0" tIns="0" bIns="0">
+            <a:spAutoFit/>
+          </a:bodyPr>
+          <a:lstStyle/>
+          <a:p>
+            <a:pPr algn="ctr"/>
+            <a:r>
+              <a:rPr sz="1200" b="1">
+                <a:solidFill>
+                  <a:srgbClr val="FFFFFF"/>
+                </a:solidFill>
+                <a:latin typeface="Aptos"/>
+              </a:rPr>
+              <a:t>Ready</a:t>
+            </a:r>
+          </a:p>
+        </p:txBody>
+      </p:sp>
+      <p:sp>
+        <p:nvSpPr>
+          <p:cNvPr id="85" name="Rounded Rectangle 84"/>
+          <p:cNvSpPr/>
+          <p:nvPr/>
+        </p:nvSpPr>
+        <p:spPr>
+          <a:xfrm>
+            <a:off x="6409944" y="3675887"/>
+            <a:ext cx="2057400" cy="384048"/>
+          </a:xfrm>
+          <a:prstGeom prst="roundRect">
+            <a:avLst/>
+          </a:prstGeom>
+          <a:solidFill>
+            <a:srgbClr val="EAB308"/>
+          </a:solidFill>
+          <a:ln>
+            <a:noFill/>
+          </a:ln>
+        </p:spPr>
+        <p:style>
+          <a:lnRef idx="1">
+            <a:schemeClr val="accent1"/>
+          </a:lnRef>
+          <a:fillRef idx="3">
+            <a:schemeClr val="accent1"/>
+          </a:fillRef>
+          <a:effectRef idx="2">
+            <a:schemeClr val="accent1"/>
+          </a:effectRef>
+          <a:fontRef idx="minor">
+            <a:schemeClr val="lt1"/>
+          </a:fontRef>
+        </p:style>
+        <p:txBody>
+          <a:bodyPr rtlCol="0" anchor="ctr"/>
+          <a:lstStyle/>
+          <a:p>
+            <a:pPr algn="ctr"/>
+          </a:p>
+        </p:txBody>
+      </p:sp>
+      <p:sp>
+        <p:nvSpPr>
+          <p:cNvPr id="86" name="TextBox 85"/>
+          <p:cNvSpPr txBox="1"/>
+          <p:nvPr/>
+        </p:nvSpPr>
+        <p:spPr>
+          <a:xfrm>
+            <a:off x="6501383" y="3749039"/>
+            <a:ext cx="1874519" cy="219456"/>
+          </a:xfrm>
+          <a:prstGeom prst="rect">
+            <a:avLst/>
+          </a:prstGeom>
+          <a:noFill/>
+        </p:spPr>
+        <p:txBody>
+          <a:bodyPr wrap="square" lIns="0" rIns="0" tIns="0" bIns="0">
+            <a:spAutoFit/>
+          </a:bodyPr>
+          <a:lstStyle/>
+          <a:p>
+            <a:pPr algn="ctr"/>
+            <a:r>
+              <a:rPr sz="1200" b="1">
+                <a:solidFill>
+                  <a:srgbClr val="1E2761"/>
+                </a:solidFill>
+                <a:latin typeface="Aptos"/>
+              </a:rPr>
+              <a:t>Ready w/ conditions</a:t>
+            </a:r>
+          </a:p>
+        </p:txBody>
+      </p:sp>
+      <p:sp>
+        <p:nvSpPr>
+          <p:cNvPr id="87" name="Rounded Rectangle 86"/>
+          <p:cNvSpPr/>
+          <p:nvPr/>
+        </p:nvSpPr>
+        <p:spPr>
+          <a:xfrm>
+            <a:off x="8540496" y="3675887"/>
+            <a:ext cx="2057400" cy="384048"/>
+          </a:xfrm>
+          <a:prstGeom prst="roundRect">
+            <a:avLst/>
+          </a:prstGeom>
+          <a:solidFill>
+            <a:srgbClr val="DC2626"/>
+          </a:solidFill>
+          <a:ln>
+            <a:noFill/>
+          </a:ln>
+        </p:spPr>
+        <p:style>
+          <a:lnRef idx="1">
+            <a:schemeClr val="accent1"/>
+          </a:lnRef>
+          <a:fillRef idx="3">
+            <a:schemeClr val="accent1"/>
+          </a:fillRef>
+          <a:effectRef idx="2">
+            <a:schemeClr val="accent1"/>
+          </a:effectRef>
+          <a:fontRef idx="minor">
+            <a:schemeClr val="lt1"/>
+          </a:fontRef>
+        </p:style>
+        <p:txBody>
+          <a:bodyPr rtlCol="0" anchor="ctr"/>
+          <a:lstStyle/>
+          <a:p>
+            <a:pPr algn="ctr"/>
+          </a:p>
+        </p:txBody>
+      </p:sp>
+      <p:sp>
+        <p:nvSpPr>
+          <p:cNvPr id="88" name="TextBox 87"/>
+          <p:cNvSpPr txBox="1"/>
+          <p:nvPr/>
+        </p:nvSpPr>
+        <p:spPr>
+          <a:xfrm>
+            <a:off x="8631936" y="3749039"/>
+            <a:ext cx="1874519" cy="219456"/>
+          </a:xfrm>
+          <a:prstGeom prst="rect">
+            <a:avLst/>
+          </a:prstGeom>
+          <a:noFill/>
+        </p:spPr>
+        <p:txBody>
+          <a:bodyPr wrap="square" lIns="0" rIns="0" tIns="0" bIns="0">
+            <a:spAutoFit/>
+          </a:bodyPr>
+          <a:lstStyle/>
+          <a:p>
+            <a:pPr algn="ctr"/>
+            <a:r>
+              <a:rPr sz="1200" b="1">
+                <a:solidFill>
+                  <a:srgbClr val="FFFFFF"/>
+                </a:solidFill>
+                <a:latin typeface="Aptos"/>
+              </a:rPr>
+              <a:t>Not ready</a:t>
+            </a:r>
+          </a:p>
+        </p:txBody>
+      </p:sp>
+      <p:sp>
+        <p:nvSpPr>
+          <p:cNvPr id="89" name="TextBox 88"/>
+          <p:cNvSpPr txBox="1"/>
+          <p:nvPr/>
+        </p:nvSpPr>
+        <p:spPr>
+          <a:xfrm>
+            <a:off x="868680" y="4160520"/>
+            <a:ext cx="1143000" cy="274320"/>
+          </a:xfrm>
+          <a:prstGeom prst="rect">
+            <a:avLst/>
+          </a:prstGeom>
+          <a:noFill/>
+        </p:spPr>
+        <p:txBody>
+          <a:bodyPr wrap="square" lIns="0" rIns="0" tIns="0" bIns="0">
+            <a:spAutoFit/>
+          </a:bodyPr>
+          <a:lstStyle/>
+          <a:p>
+            <a:r>
+              <a:rPr sz="1400" b="1">
+                <a:solidFill>
+                  <a:srgbClr val="1E2761"/>
+                </a:solidFill>
+                <a:latin typeface="Aptos"/>
+              </a:rPr>
+              <a:t>MongoDB</a:t>
+            </a:r>
+          </a:p>
+        </p:txBody>
+      </p:sp>
+      <p:sp>
+        <p:nvSpPr>
+          <p:cNvPr id="90" name="Rounded Rectangle 89"/>
+          <p:cNvSpPr/>
+          <p:nvPr/>
+        </p:nvSpPr>
+        <p:spPr>
+          <a:xfrm>
+            <a:off x="2148840" y="4114800"/>
+            <a:ext cx="2057400" cy="384048"/>
+          </a:xfrm>
+          <a:prstGeom prst="roundRect">
+            <a:avLst/>
+          </a:prstGeom>
+          <a:solidFill>
+            <a:srgbClr val="E7EAEF"/>
+          </a:solidFill>
+          <a:ln w="12700">
+            <a:solidFill>
+              <a:srgbClr val="FFFFFF"/>
+            </a:solidFill>
+          </a:ln>
+        </p:spPr>
+        <p:style>
+          <a:lnRef idx="1">
+            <a:schemeClr val="accent1"/>
+          </a:lnRef>
+          <a:fillRef idx="3">
+            <a:schemeClr val="accent1"/>
+          </a:fillRef>
+          <a:effectRef idx="2">
+            <a:schemeClr val="accent1"/>
+          </a:effectRef>
+          <a:fontRef idx="minor">
+            <a:schemeClr val="lt1"/>
+          </a:fontRef>
+        </p:style>
+        <p:txBody>
+          <a:bodyPr rtlCol="0" anchor="ctr"/>
+          <a:lstStyle/>
+          <a:p>
+            <a:pPr algn="ctr"/>
+          </a:p>
+        </p:txBody>
+      </p:sp>
+      <p:sp>
+        <p:nvSpPr>
+          <p:cNvPr id="91" name="TextBox 90"/>
+          <p:cNvSpPr txBox="1"/>
+          <p:nvPr/>
+        </p:nvSpPr>
+        <p:spPr>
+          <a:xfrm>
+            <a:off x="2240280" y="4197096"/>
+            <a:ext cx="1874519" cy="164592"/>
+          </a:xfrm>
+          <a:prstGeom prst="rect">
+            <a:avLst/>
+          </a:prstGeom>
+          <a:noFill/>
+        </p:spPr>
+        <p:txBody>
+          <a:bodyPr wrap="square" lIns="0" rIns="0" tIns="0" bIns="0">
+            <a:spAutoFit/>
+          </a:bodyPr>
+          <a:lstStyle/>
+          <a:p>
+            <a:pPr algn="ctr"/>
+            <a:r>
+              <a:rPr sz="1100" b="1">
                 <a:solidFill>
                   <a:srgbClr val="1E2761"/>
                 </a:solidFill>
@@ -16241,14 +19065,94 @@
       </p:sp>
       <p:sp>
         <p:nvSpPr>
-          <p:cNvPr id="20" name="Rounded Rectangle 19"/>
+          <p:cNvPr id="92" name="Rounded Rectangle 91"/>
           <p:cNvSpPr/>
           <p:nvPr/>
         </p:nvSpPr>
         <p:spPr>
           <a:xfrm>
-            <a:off x="6592824" y="2788920"/>
-            <a:ext cx="2057400" cy="658368"/>
+            <a:off x="4279392" y="4114800"/>
+            <a:ext cx="2057400" cy="384048"/>
+          </a:xfrm>
+          <a:prstGeom prst="roundRect">
+            <a:avLst/>
+          </a:prstGeom>
+          <a:solidFill>
+            <a:srgbClr val="CEE5CE"/>
+          </a:solidFill>
+          <a:ln w="12700">
+            <a:solidFill>
+              <a:srgbClr val="FFFFFF"/>
+            </a:solidFill>
+          </a:ln>
+        </p:spPr>
+        <p:style>
+          <a:lnRef idx="1">
+            <a:schemeClr val="accent1"/>
+          </a:lnRef>
+          <a:fillRef idx="3">
+            <a:schemeClr val="accent1"/>
+          </a:fillRef>
+          <a:effectRef idx="2">
+            <a:schemeClr val="accent1"/>
+          </a:effectRef>
+          <a:fontRef idx="minor">
+            <a:schemeClr val="lt1"/>
+          </a:fontRef>
+        </p:style>
+        <p:txBody>
+          <a:bodyPr rtlCol="0" anchor="ctr"/>
+          <a:lstStyle/>
+          <a:p>
+            <a:pPr algn="ctr"/>
+          </a:p>
+        </p:txBody>
+      </p:sp>
+      <p:sp>
+        <p:nvSpPr>
+          <p:cNvPr id="93" name="TextBox 92"/>
+          <p:cNvSpPr txBox="1"/>
+          <p:nvPr/>
+        </p:nvSpPr>
+        <p:spPr>
+          <a:xfrm>
+            <a:off x="4370831" y="4197096"/>
+            <a:ext cx="1874519" cy="164592"/>
+          </a:xfrm>
+          <a:prstGeom prst="rect">
+            <a:avLst/>
+          </a:prstGeom>
+          <a:noFill/>
+        </p:spPr>
+        <p:txBody>
+          <a:bodyPr wrap="square" lIns="0" rIns="0" tIns="0" bIns="0">
+            <a:spAutoFit/>
+          </a:bodyPr>
+          <a:lstStyle/>
+          <a:p>
+            <a:pPr algn="ctr"/>
+            <a:r>
+              <a:rPr sz="1100" b="1">
+                <a:solidFill>
+                  <a:srgbClr val="1E2761"/>
+                </a:solidFill>
+                <a:latin typeface="Aptos"/>
+              </a:rPr>
+              <a:t>0</a:t>
+            </a:r>
+          </a:p>
+        </p:txBody>
+      </p:sp>
+      <p:sp>
+        <p:nvSpPr>
+          <p:cNvPr id="94" name="Rounded Rectangle 93"/>
+          <p:cNvSpPr/>
+          <p:nvPr/>
+        </p:nvSpPr>
+        <p:spPr>
+          <a:xfrm>
+            <a:off x="6409944" y="4114800"/>
+            <a:ext cx="2057400" cy="384048"/>
           </a:xfrm>
           <a:prstGeom prst="roundRect">
             <a:avLst/>
@@ -16286,14 +19190,14 @@
       </p:sp>
       <p:sp>
         <p:nvSpPr>
-          <p:cNvPr id="21" name="TextBox 20"/>
+          <p:cNvPr id="95" name="TextBox 94"/>
           <p:cNvSpPr txBox="1"/>
           <p:nvPr/>
         </p:nvSpPr>
         <p:spPr>
           <a:xfrm>
-            <a:off x="6684264" y="2953512"/>
-            <a:ext cx="1874519" cy="256032"/>
+            <a:off x="6501383" y="4197096"/>
+            <a:ext cx="1874519" cy="164592"/>
           </a:xfrm>
           <a:prstGeom prst="rect">
             <a:avLst/>
@@ -16308,7 +19212,7 @@
           <a:p>
             <a:pPr algn="ctr"/>
             <a:r>
-              <a:rPr sz="1600" b="1">
+              <a:rPr sz="1100" b="1">
                 <a:solidFill>
                   <a:srgbClr val="1E2761"/>
                 </a:solidFill>
@@ -16321,14 +19225,14 @@
       </p:sp>
       <p:sp>
         <p:nvSpPr>
-          <p:cNvPr id="22" name="Rounded Rectangle 21"/>
+          <p:cNvPr id="96" name="Rounded Rectangle 95"/>
           <p:cNvSpPr/>
           <p:nvPr/>
         </p:nvSpPr>
         <p:spPr>
           <a:xfrm>
-            <a:off x="8723376" y="2788920"/>
-            <a:ext cx="2057400" cy="658368"/>
+            <a:off x="8540496" y="4114800"/>
+            <a:ext cx="2057400" cy="384048"/>
           </a:xfrm>
           <a:prstGeom prst="roundRect">
             <a:avLst/>
@@ -16366,14 +19270,14 @@
       </p:sp>
       <p:sp>
         <p:nvSpPr>
-          <p:cNvPr id="23" name="TextBox 22"/>
+          <p:cNvPr id="97" name="TextBox 96"/>
           <p:cNvSpPr txBox="1"/>
           <p:nvPr/>
         </p:nvSpPr>
         <p:spPr>
           <a:xfrm>
-            <a:off x="8814815" y="2953512"/>
-            <a:ext cx="1874519" cy="256032"/>
+            <a:off x="8631936" y="4197096"/>
+            <a:ext cx="1874519" cy="164592"/>
           </a:xfrm>
           <a:prstGeom prst="rect">
             <a:avLst/>
@@ -16388,7 +19292,7 @@
           <a:p>
             <a:pPr algn="ctr"/>
             <a:r>
-              <a:rPr sz="1600" b="1">
+              <a:rPr sz="1100" b="1">
                 <a:solidFill>
                   <a:srgbClr val="1E2761"/>
                 </a:solidFill>
@@ -16401,14 +19305,14 @@
       </p:sp>
       <p:sp>
         <p:nvSpPr>
-          <p:cNvPr id="24" name="TextBox 23"/>
+          <p:cNvPr id="98" name="TextBox 97"/>
           <p:cNvSpPr txBox="1"/>
           <p:nvPr/>
         </p:nvSpPr>
         <p:spPr>
           <a:xfrm>
-            <a:off x="914400" y="3703320"/>
-            <a:ext cx="1143000" cy="228600"/>
+            <a:off x="868680" y="4599431"/>
+            <a:ext cx="1143000" cy="274320"/>
           </a:xfrm>
           <a:prstGeom prst="rect">
             <a:avLst/>
@@ -16422,7 +19326,7 @@
           <a:lstStyle/>
           <a:p>
             <a:r>
-              <a:rPr sz="1200" b="1">
+              <a:rPr sz="1400" b="1">
                 <a:solidFill>
                   <a:srgbClr val="1E2761"/>
                 </a:solidFill>
@@ -16435,14 +19339,14 @@
       </p:sp>
       <p:sp>
         <p:nvSpPr>
-          <p:cNvPr id="25" name="Rounded Rectangle 24"/>
+          <p:cNvPr id="99" name="Rounded Rectangle 98"/>
           <p:cNvSpPr/>
           <p:nvPr/>
         </p:nvSpPr>
         <p:spPr>
           <a:xfrm>
-            <a:off x="2331720" y="3520439"/>
-            <a:ext cx="2057400" cy="658368"/>
+            <a:off x="2148840" y="4553712"/>
+            <a:ext cx="2057400" cy="384048"/>
           </a:xfrm>
           <a:prstGeom prst="roundRect">
             <a:avLst/>
@@ -16480,14 +19384,14 @@
       </p:sp>
       <p:sp>
         <p:nvSpPr>
-          <p:cNvPr id="26" name="TextBox 25"/>
+          <p:cNvPr id="100" name="TextBox 99"/>
           <p:cNvSpPr txBox="1"/>
           <p:nvPr/>
         </p:nvSpPr>
         <p:spPr>
           <a:xfrm>
-            <a:off x="2423160" y="3685031"/>
-            <a:ext cx="1874519" cy="256032"/>
+            <a:off x="2240280" y="4636007"/>
+            <a:ext cx="1874519" cy="164592"/>
           </a:xfrm>
           <a:prstGeom prst="rect">
             <a:avLst/>
@@ -16502,7 +19406,7 @@
           <a:p>
             <a:pPr algn="ctr"/>
             <a:r>
-              <a:rPr sz="1600" b="1">
+              <a:rPr sz="1100" b="1">
                 <a:solidFill>
                   <a:srgbClr val="1E2761"/>
                 </a:solidFill>
@@ -16515,14 +19419,14 @@
       </p:sp>
       <p:sp>
         <p:nvSpPr>
-          <p:cNvPr id="27" name="Rounded Rectangle 26"/>
+          <p:cNvPr id="101" name="Rounded Rectangle 100"/>
           <p:cNvSpPr/>
           <p:nvPr/>
         </p:nvSpPr>
         <p:spPr>
           <a:xfrm>
-            <a:off x="4462272" y="3520439"/>
-            <a:ext cx="2057400" cy="658368"/>
+            <a:off x="4279392" y="4553712"/>
+            <a:ext cx="2057400" cy="384048"/>
           </a:xfrm>
           <a:prstGeom prst="roundRect">
             <a:avLst/>
@@ -16560,14 +19464,14 @@
       </p:sp>
       <p:sp>
         <p:nvSpPr>
-          <p:cNvPr id="28" name="TextBox 27"/>
+          <p:cNvPr id="102" name="TextBox 101"/>
           <p:cNvSpPr txBox="1"/>
           <p:nvPr/>
         </p:nvSpPr>
         <p:spPr>
           <a:xfrm>
-            <a:off x="4553712" y="3685031"/>
-            <a:ext cx="1874519" cy="256032"/>
+            <a:off x="4370831" y="4636007"/>
+            <a:ext cx="1874519" cy="164592"/>
           </a:xfrm>
           <a:prstGeom prst="rect">
             <a:avLst/>
@@ -16582,7 +19486,7 @@
           <a:p>
             <a:pPr algn="ctr"/>
             <a:r>
-              <a:rPr sz="1600" b="1">
+              <a:rPr sz="1100" b="1">
                 <a:solidFill>
                   <a:srgbClr val="1E2761"/>
                 </a:solidFill>
@@ -16595,14 +19499,14 @@
       </p:sp>
       <p:sp>
         <p:nvSpPr>
-          <p:cNvPr id="29" name="Rounded Rectangle 28"/>
+          <p:cNvPr id="103" name="Rounded Rectangle 102"/>
           <p:cNvSpPr/>
           <p:nvPr/>
         </p:nvSpPr>
         <p:spPr>
           <a:xfrm>
-            <a:off x="6592824" y="3520439"/>
-            <a:ext cx="2057400" cy="658368"/>
+            <a:off x="6409944" y="4553712"/>
+            <a:ext cx="2057400" cy="384048"/>
           </a:xfrm>
           <a:prstGeom prst="roundRect">
             <a:avLst/>
@@ -16640,14 +19544,14 @@
       </p:sp>
       <p:sp>
         <p:nvSpPr>
-          <p:cNvPr id="30" name="TextBox 29"/>
+          <p:cNvPr id="104" name="TextBox 103"/>
           <p:cNvSpPr txBox="1"/>
           <p:nvPr/>
         </p:nvSpPr>
         <p:spPr>
           <a:xfrm>
-            <a:off x="6684264" y="3685031"/>
-            <a:ext cx="1874519" cy="256032"/>
+            <a:off x="6501383" y="4636007"/>
+            <a:ext cx="1874519" cy="164592"/>
           </a:xfrm>
           <a:prstGeom prst="rect">
             <a:avLst/>
@@ -16662,7 +19566,7 @@
           <a:p>
             <a:pPr algn="ctr"/>
             <a:r>
-              <a:rPr sz="1600" b="1">
+              <a:rPr sz="1100" b="1">
                 <a:solidFill>
                   <a:srgbClr val="1E2761"/>
                 </a:solidFill>
@@ -16675,14 +19579,14 @@
       </p:sp>
       <p:sp>
         <p:nvSpPr>
-          <p:cNvPr id="31" name="Rounded Rectangle 30"/>
+          <p:cNvPr id="105" name="Rounded Rectangle 104"/>
           <p:cNvSpPr/>
           <p:nvPr/>
         </p:nvSpPr>
         <p:spPr>
           <a:xfrm>
-            <a:off x="8723376" y="3520439"/>
-            <a:ext cx="2057400" cy="658368"/>
+            <a:off x="8540496" y="4553712"/>
+            <a:ext cx="2057400" cy="384048"/>
           </a:xfrm>
           <a:prstGeom prst="roundRect">
             <a:avLst/>
@@ -16720,14 +19624,14 @@
       </p:sp>
       <p:sp>
         <p:nvSpPr>
-          <p:cNvPr id="32" name="TextBox 31"/>
+          <p:cNvPr id="106" name="TextBox 105"/>
           <p:cNvSpPr txBox="1"/>
           <p:nvPr/>
         </p:nvSpPr>
         <p:spPr>
           <a:xfrm>
-            <a:off x="8814815" y="3685031"/>
-            <a:ext cx="1874519" cy="256032"/>
+            <a:off x="8631936" y="4636007"/>
+            <a:ext cx="1874519" cy="164592"/>
           </a:xfrm>
           <a:prstGeom prst="rect">
             <a:avLst/>
@@ -16742,7 +19646,7 @@
           <a:p>
             <a:pPr algn="ctr"/>
             <a:r>
-              <a:rPr sz="1600" b="1">
+              <a:rPr sz="1100" b="1">
                 <a:solidFill>
                   <a:srgbClr val="1E2761"/>
                 </a:solidFill>
@@ -16755,14 +19659,14 @@
       </p:sp>
       <p:sp>
         <p:nvSpPr>
-          <p:cNvPr id="33" name="TextBox 32"/>
+          <p:cNvPr id="107" name="TextBox 106"/>
           <p:cNvSpPr txBox="1"/>
           <p:nvPr/>
         </p:nvSpPr>
         <p:spPr>
           <a:xfrm>
-            <a:off x="914400" y="4434840"/>
-            <a:ext cx="1143000" cy="228600"/>
+            <a:off x="868680" y="5038343"/>
+            <a:ext cx="1143000" cy="274320"/>
           </a:xfrm>
           <a:prstGeom prst="rect">
             <a:avLst/>
@@ -16776,7 +19680,7 @@
           <a:lstStyle/>
           <a:p>
             <a:r>
-              <a:rPr sz="1200" b="1">
+              <a:rPr sz="1400" b="1">
                 <a:solidFill>
                   <a:srgbClr val="1E2761"/>
                 </a:solidFill>
@@ -16789,14 +19693,14 @@
       </p:sp>
       <p:sp>
         <p:nvSpPr>
-          <p:cNvPr id="34" name="Rounded Rectangle 33"/>
+          <p:cNvPr id="108" name="Rounded Rectangle 107"/>
           <p:cNvSpPr/>
           <p:nvPr/>
         </p:nvSpPr>
         <p:spPr>
           <a:xfrm>
-            <a:off x="2331720" y="4251960"/>
-            <a:ext cx="2057400" cy="658368"/>
+            <a:off x="2148840" y="4992623"/>
+            <a:ext cx="2057400" cy="384048"/>
           </a:xfrm>
           <a:prstGeom prst="roundRect">
             <a:avLst/>
@@ -16834,14 +19738,14 @@
       </p:sp>
       <p:sp>
         <p:nvSpPr>
-          <p:cNvPr id="35" name="TextBox 34"/>
+          <p:cNvPr id="109" name="TextBox 108"/>
           <p:cNvSpPr txBox="1"/>
           <p:nvPr/>
         </p:nvSpPr>
         <p:spPr>
           <a:xfrm>
-            <a:off x="2423160" y="4416552"/>
-            <a:ext cx="1874519" cy="256032"/>
+            <a:off x="2240280" y="5074919"/>
+            <a:ext cx="1874519" cy="164592"/>
           </a:xfrm>
           <a:prstGeom prst="rect">
             <a:avLst/>
@@ -16856,7 +19760,7 @@
           <a:p>
             <a:pPr algn="ctr"/>
             <a:r>
-              <a:rPr sz="1600" b="1">
+              <a:rPr sz="1100" b="1">
                 <a:solidFill>
                   <a:srgbClr val="1E2761"/>
                 </a:solidFill>
@@ -16869,14 +19773,14 @@
       </p:sp>
       <p:sp>
         <p:nvSpPr>
-          <p:cNvPr id="36" name="Rounded Rectangle 35"/>
+          <p:cNvPr id="110" name="Rounded Rectangle 109"/>
           <p:cNvSpPr/>
           <p:nvPr/>
         </p:nvSpPr>
         <p:spPr>
           <a:xfrm>
-            <a:off x="4462272" y="4251960"/>
-            <a:ext cx="2057400" cy="658368"/>
+            <a:off x="4279392" y="4992623"/>
+            <a:ext cx="2057400" cy="384048"/>
           </a:xfrm>
           <a:prstGeom prst="roundRect">
             <a:avLst/>
@@ -16914,14 +19818,14 @@
       </p:sp>
       <p:sp>
         <p:nvSpPr>
-          <p:cNvPr id="37" name="TextBox 36"/>
+          <p:cNvPr id="111" name="TextBox 110"/>
           <p:cNvSpPr txBox="1"/>
           <p:nvPr/>
         </p:nvSpPr>
         <p:spPr>
           <a:xfrm>
-            <a:off x="4553712" y="4416552"/>
-            <a:ext cx="1874519" cy="256032"/>
+            <a:off x="4370831" y="5074919"/>
+            <a:ext cx="1874519" cy="164592"/>
           </a:xfrm>
           <a:prstGeom prst="rect">
             <a:avLst/>
@@ -16936,7 +19840,7 @@
           <a:p>
             <a:pPr algn="ctr"/>
             <a:r>
-              <a:rPr sz="1600" b="1">
+              <a:rPr sz="1100" b="1">
                 <a:solidFill>
                   <a:srgbClr val="1E2761"/>
                 </a:solidFill>
@@ -16949,14 +19853,14 @@
       </p:sp>
       <p:sp>
         <p:nvSpPr>
-          <p:cNvPr id="38" name="Rounded Rectangle 37"/>
+          <p:cNvPr id="112" name="Rounded Rectangle 111"/>
           <p:cNvSpPr/>
           <p:nvPr/>
         </p:nvSpPr>
         <p:spPr>
           <a:xfrm>
-            <a:off x="6592824" y="4251960"/>
-            <a:ext cx="2057400" cy="658368"/>
+            <a:off x="6409944" y="4992623"/>
+            <a:ext cx="2057400" cy="384048"/>
           </a:xfrm>
           <a:prstGeom prst="roundRect">
             <a:avLst/>
@@ -16994,14 +19898,14 @@
       </p:sp>
       <p:sp>
         <p:nvSpPr>
-          <p:cNvPr id="39" name="TextBox 38"/>
+          <p:cNvPr id="113" name="TextBox 112"/>
           <p:cNvSpPr txBox="1"/>
           <p:nvPr/>
         </p:nvSpPr>
         <p:spPr>
           <a:xfrm>
-            <a:off x="6684264" y="4416552"/>
-            <a:ext cx="1874519" cy="256032"/>
+            <a:off x="6501383" y="5074919"/>
+            <a:ext cx="1874519" cy="164592"/>
           </a:xfrm>
           <a:prstGeom prst="rect">
             <a:avLst/>
@@ -17016,7 +19920,7 @@
           <a:p>
             <a:pPr algn="ctr"/>
             <a:r>
-              <a:rPr sz="1600" b="1">
+              <a:rPr sz="1100" b="1">
                 <a:solidFill>
                   <a:srgbClr val="1E2761"/>
                 </a:solidFill>
@@ -17029,14 +19933,14 @@
       </p:sp>
       <p:sp>
         <p:nvSpPr>
-          <p:cNvPr id="40" name="Rounded Rectangle 39"/>
+          <p:cNvPr id="114" name="Rounded Rectangle 113"/>
           <p:cNvSpPr/>
           <p:nvPr/>
         </p:nvSpPr>
         <p:spPr>
           <a:xfrm>
-            <a:off x="8723376" y="4251960"/>
-            <a:ext cx="2057400" cy="658368"/>
+            <a:off x="8540496" y="4992623"/>
+            <a:ext cx="2057400" cy="384048"/>
           </a:xfrm>
           <a:prstGeom prst="roundRect">
             <a:avLst/>
@@ -17074,14 +19978,14 @@
       </p:sp>
       <p:sp>
         <p:nvSpPr>
-          <p:cNvPr id="41" name="TextBox 40"/>
+          <p:cNvPr id="115" name="TextBox 114"/>
           <p:cNvSpPr txBox="1"/>
           <p:nvPr/>
         </p:nvSpPr>
         <p:spPr>
           <a:xfrm>
-            <a:off x="8814815" y="4416552"/>
-            <a:ext cx="1874519" cy="256032"/>
+            <a:off x="8631936" y="5074919"/>
+            <a:ext cx="1874519" cy="164592"/>
           </a:xfrm>
           <a:prstGeom prst="rect">
             <a:avLst/>
@@ -17096,7 +20000,7 @@
           <a:p>
             <a:pPr algn="ctr"/>
             <a:r>
-              <a:rPr sz="1600" b="1">
+              <a:rPr sz="1100" b="1">
                 <a:solidFill>
                   <a:srgbClr val="1E2761"/>
                 </a:solidFill>
@@ -17109,14 +20013,14 @@
       </p:sp>
       <p:sp>
         <p:nvSpPr>
-          <p:cNvPr id="42" name="TextBox 41"/>
+          <p:cNvPr id="116" name="TextBox 115"/>
           <p:cNvSpPr txBox="1"/>
           <p:nvPr/>
         </p:nvSpPr>
         <p:spPr>
           <a:xfrm>
-            <a:off x="914400" y="5166359"/>
-            <a:ext cx="1143000" cy="228600"/>
+            <a:off x="868680" y="5477255"/>
+            <a:ext cx="1143000" cy="274320"/>
           </a:xfrm>
           <a:prstGeom prst="rect">
             <a:avLst/>
@@ -17130,7 +20034,7 @@
           <a:lstStyle/>
           <a:p>
             <a:r>
-              <a:rPr sz="1200" b="1">
+              <a:rPr sz="1400" b="1">
                 <a:solidFill>
                   <a:srgbClr val="1E2761"/>
                 </a:solidFill>
@@ -17143,14 +20047,14 @@
       </p:sp>
       <p:sp>
         <p:nvSpPr>
-          <p:cNvPr id="43" name="Rounded Rectangle 42"/>
+          <p:cNvPr id="117" name="Rounded Rectangle 116"/>
           <p:cNvSpPr/>
           <p:nvPr/>
         </p:nvSpPr>
         <p:spPr>
           <a:xfrm>
-            <a:off x="2331720" y="4983479"/>
-            <a:ext cx="2057400" cy="658368"/>
+            <a:off x="2148840" y="5431536"/>
+            <a:ext cx="2057400" cy="384048"/>
           </a:xfrm>
           <a:prstGeom prst="roundRect">
             <a:avLst/>
@@ -17188,14 +20092,14 @@
       </p:sp>
       <p:sp>
         <p:nvSpPr>
-          <p:cNvPr id="44" name="TextBox 43"/>
+          <p:cNvPr id="118" name="TextBox 117"/>
           <p:cNvSpPr txBox="1"/>
           <p:nvPr/>
         </p:nvSpPr>
         <p:spPr>
           <a:xfrm>
-            <a:off x="2423160" y="5148071"/>
-            <a:ext cx="1874519" cy="256032"/>
+            <a:off x="2240280" y="5513831"/>
+            <a:ext cx="1874519" cy="164592"/>
           </a:xfrm>
           <a:prstGeom prst="rect">
             <a:avLst/>
@@ -17210,7 +20114,7 @@
           <a:p>
             <a:pPr algn="ctr"/>
             <a:r>
-              <a:rPr sz="1600" b="1">
+              <a:rPr sz="1100" b="1">
                 <a:solidFill>
                   <a:srgbClr val="FFFFFF"/>
                 </a:solidFill>
@@ -17223,14 +20127,14 @@
       </p:sp>
       <p:sp>
         <p:nvSpPr>
-          <p:cNvPr id="45" name="Rounded Rectangle 44"/>
+          <p:cNvPr id="119" name="Rounded Rectangle 118"/>
           <p:cNvSpPr/>
           <p:nvPr/>
         </p:nvSpPr>
         <p:spPr>
           <a:xfrm>
-            <a:off x="4462272" y="4983479"/>
-            <a:ext cx="2057400" cy="658368"/>
+            <a:off x="4279392" y="5431536"/>
+            <a:ext cx="2057400" cy="384048"/>
           </a:xfrm>
           <a:prstGeom prst="roundRect">
             <a:avLst/>
@@ -17268,14 +20172,14 @@
       </p:sp>
       <p:sp>
         <p:nvSpPr>
-          <p:cNvPr id="46" name="TextBox 45"/>
+          <p:cNvPr id="120" name="TextBox 119"/>
           <p:cNvSpPr txBox="1"/>
           <p:nvPr/>
         </p:nvSpPr>
         <p:spPr>
           <a:xfrm>
-            <a:off x="4553712" y="5148071"/>
-            <a:ext cx="1874519" cy="256032"/>
+            <a:off x="4370831" y="5513831"/>
+            <a:ext cx="1874519" cy="164592"/>
           </a:xfrm>
           <a:prstGeom prst="rect">
             <a:avLst/>
@@ -17290,7 +20194,7 @@
           <a:p>
             <a:pPr algn="ctr"/>
             <a:r>
-              <a:rPr sz="1600" b="1">
+              <a:rPr sz="1100" b="1">
                 <a:solidFill>
                   <a:srgbClr val="FFFFFF"/>
                 </a:solidFill>
@@ -17303,14 +20207,14 @@
       </p:sp>
       <p:sp>
         <p:nvSpPr>
-          <p:cNvPr id="47" name="Rounded Rectangle 46"/>
+          <p:cNvPr id="121" name="Rounded Rectangle 120"/>
           <p:cNvSpPr/>
           <p:nvPr/>
         </p:nvSpPr>
         <p:spPr>
           <a:xfrm>
-            <a:off x="6592824" y="4983479"/>
-            <a:ext cx="2057400" cy="658368"/>
+            <a:off x="6409944" y="5431536"/>
+            <a:ext cx="2057400" cy="384048"/>
           </a:xfrm>
           <a:prstGeom prst="roundRect">
             <a:avLst/>
@@ -17348,14 +20252,14 @@
       </p:sp>
       <p:sp>
         <p:nvSpPr>
-          <p:cNvPr id="48" name="TextBox 47"/>
+          <p:cNvPr id="122" name="TextBox 121"/>
           <p:cNvSpPr txBox="1"/>
           <p:nvPr/>
         </p:nvSpPr>
         <p:spPr>
           <a:xfrm>
-            <a:off x="6684264" y="5148071"/>
-            <a:ext cx="1874519" cy="256032"/>
+            <a:off x="6501383" y="5513831"/>
+            <a:ext cx="1874519" cy="164592"/>
           </a:xfrm>
           <a:prstGeom prst="rect">
             <a:avLst/>
@@ -17370,7 +20274,7 @@
           <a:p>
             <a:pPr algn="ctr"/>
             <a:r>
-              <a:rPr sz="1600" b="1">
+              <a:rPr sz="1100" b="1">
                 <a:solidFill>
                   <a:srgbClr val="1E2761"/>
                 </a:solidFill>
@@ -17383,14 +20287,14 @@
       </p:sp>
       <p:sp>
         <p:nvSpPr>
-          <p:cNvPr id="49" name="Rounded Rectangle 48"/>
+          <p:cNvPr id="123" name="Rounded Rectangle 122"/>
           <p:cNvSpPr/>
           <p:nvPr/>
         </p:nvSpPr>
         <p:spPr>
           <a:xfrm>
-            <a:off x="8723376" y="4983479"/>
-            <a:ext cx="2057400" cy="658368"/>
+            <a:off x="8540496" y="5431536"/>
+            <a:ext cx="2057400" cy="384048"/>
           </a:xfrm>
           <a:prstGeom prst="roundRect">
             <a:avLst/>
@@ -17428,14 +20332,14 @@
       </p:sp>
       <p:sp>
         <p:nvSpPr>
-          <p:cNvPr id="50" name="TextBox 49"/>
+          <p:cNvPr id="124" name="TextBox 123"/>
           <p:cNvSpPr txBox="1"/>
           <p:nvPr/>
         </p:nvSpPr>
         <p:spPr>
           <a:xfrm>
-            <a:off x="8814815" y="5148071"/>
-            <a:ext cx="1874519" cy="256032"/>
+            <a:off x="8631936" y="5513831"/>
+            <a:ext cx="1874519" cy="164592"/>
           </a:xfrm>
           <a:prstGeom prst="rect">
             <a:avLst/>
@@ -17450,7 +20354,7 @@
           <a:p>
             <a:pPr algn="ctr"/>
             <a:r>
-              <a:rPr sz="1600" b="1">
+              <a:rPr sz="1100" b="1">
                 <a:solidFill>
                   <a:srgbClr val="FFFFFF"/>
                 </a:solidFill>
@@ -17463,14 +20367,14 @@
       </p:sp>
       <p:sp>
         <p:nvSpPr>
-          <p:cNvPr id="51" name="TextBox 50"/>
+          <p:cNvPr id="125" name="TextBox 124"/>
           <p:cNvSpPr txBox="1"/>
           <p:nvPr/>
         </p:nvSpPr>
         <p:spPr>
           <a:xfrm>
-            <a:off x="914400" y="5532120"/>
-            <a:ext cx="4343400" cy="228600"/>
+            <a:off x="548640" y="6327648"/>
+            <a:ext cx="11064240" cy="164592"/>
           </a:xfrm>
           <a:prstGeom prst="rect">
             <a:avLst/>
@@ -17484,47 +20388,13 @@
           <a:lstStyle/>
           <a:p>
             <a:r>
-              <a:rPr sz="1100" b="1">
-                <a:solidFill>
-                  <a:srgbClr val="36454F"/>
+              <a:rPr sz="700" b="0">
+                <a:solidFill>
+                  <a:srgbClr val="64748B"/>
                 </a:solidFill>
                 <a:latin typeface="Aptos"/>
               </a:rPr>
-              <a:t>Total non-SQL database rows assessed: 37</a:t>
-            </a:r>
-          </a:p>
-        </p:txBody>
-      </p:sp>
-      <p:sp>
-        <p:nvSpPr>
-          <p:cNvPr id="52" name="TextBox 51"/>
-          <p:cNvSpPr txBox="1"/>
-          <p:nvPr/>
-        </p:nvSpPr>
-        <p:spPr>
-          <a:xfrm>
-            <a:off x="548640" y="6327648"/>
-            <a:ext cx="11064240" cy="164592"/>
-          </a:xfrm>
-          <a:prstGeom prst="rect">
-            <a:avLst/>
-          </a:prstGeom>
-          <a:noFill/>
-        </p:spPr>
-        <p:txBody>
-          <a:bodyPr wrap="square" lIns="0" rIns="0" tIns="0" bIns="0">
-            <a:spAutoFit/>
-          </a:bodyPr>
-          <a:lstStyle/>
-          <a:p>
-            <a:r>
-              <a:rPr sz="800" b="0">
-                <a:solidFill>
-                  <a:srgbClr val="64748B"/>
-                </a:solidFill>
-                <a:latin typeface="Aptos"/>
-              </a:rPr>
-              <a:t>Source: Strategy_PaaS_Preferred.xlsx sheets Mongo_to_Azure_Document_DB, MySQL_to_AzureFlexServerMySQL, and PgSQL_to_AzureFlexServerPG.</a:t>
+              <a:t>Sources: Discovery.xlsx Data sheet for instances, servers, versions, and directSupportStatus; Strategy_PaaS_Preferred.xlsx for PaaS readiness.</a:t>
             </a:r>
           </a:p>
         </p:txBody>

</xml_diff>